<commit_message>
transformer/nl-job/solo decks: remove the short accent hairline under page titles
</commit_message>
<xml_diff>
--- a/templates/decks/en/solo-company-talk/template.pptx
+++ b/templates/decks/en/solo-company-talk/template.pptx
@@ -5425,51 +5425,7 @@
       </p:sp>
       <p:sp>
         <p:nvSpPr>
-          <p:cNvPr id="5" name="Rectangle 4"/>
-          <p:cNvSpPr/>
-          <p:nvPr/>
-        </p:nvSpPr>
-        <p:spPr>
-          <a:xfrm>
-            <a:off x="566928" y="1191006"/>
-            <a:ext cx="1097280" cy="45720"/>
-          </a:xfrm>
-          <a:prstGeom prst="rect">
-            <a:avLst/>
-          </a:prstGeom>
-          <a:solidFill>
-            <a:srgbClr val="E1542A"/>
-          </a:solidFill>
-          <a:ln>
-            <a:noFill/>
-          </a:ln>
-          <a:effectLst/>
-        </p:spPr>
-        <p:style>
-          <a:lnRef idx="1">
-            <a:schemeClr val="accent1"/>
-          </a:lnRef>
-          <a:fillRef idx="3">
-            <a:schemeClr val="accent1"/>
-          </a:fillRef>
-          <a:effectRef idx="2">
-            <a:schemeClr val="accent1"/>
-          </a:effectRef>
-          <a:fontRef idx="minor">
-            <a:schemeClr val="lt1"/>
-          </a:fontRef>
-        </p:style>
-        <p:txBody>
-          <a:bodyPr rtlCol="0" anchor="ctr"/>
-          <a:lstStyle/>
-          <a:p>
-            <a:pPr algn="ctr"/>
-          </a:p>
-        </p:txBody>
-      </p:sp>
-      <p:sp>
-        <p:nvSpPr>
-          <p:cNvPr id="6" name="TextBox 5"/>
+          <p:cNvPr id="5" name="TextBox 4"/>
           <p:cNvSpPr txBox="1"/>
           <p:nvPr/>
         </p:nvSpPr>
@@ -5515,7 +5471,7 @@
       </p:sp>
       <p:sp>
         <p:nvSpPr>
-          <p:cNvPr id="7" name="TextBox 6"/>
+          <p:cNvPr id="6" name="TextBox 5"/>
           <p:cNvSpPr txBox="1"/>
           <p:nvPr/>
         </p:nvSpPr>
@@ -5561,7 +5517,7 @@
       </p:sp>
       <p:sp>
         <p:nvSpPr>
-          <p:cNvPr id="8" name="TextBox 7"/>
+          <p:cNvPr id="7" name="TextBox 6"/>
           <p:cNvSpPr txBox="1"/>
           <p:nvPr/>
         </p:nvSpPr>
@@ -5607,7 +5563,7 @@
       </p:sp>
       <p:sp>
         <p:nvSpPr>
-          <p:cNvPr id="9" name="TextBox 8"/>
+          <p:cNvPr id="8" name="TextBox 7"/>
           <p:cNvSpPr txBox="1"/>
           <p:nvPr/>
         </p:nvSpPr>
@@ -5653,7 +5609,7 @@
       </p:sp>
       <p:sp>
         <p:nvSpPr>
-          <p:cNvPr id="10" name="TextBox 9"/>
+          <p:cNvPr id="9" name="TextBox 8"/>
           <p:cNvSpPr txBox="1"/>
           <p:nvPr/>
         </p:nvSpPr>
@@ -5699,7 +5655,7 @@
       </p:sp>
       <p:sp>
         <p:nvSpPr>
-          <p:cNvPr id="11" name="TextBox 10"/>
+          <p:cNvPr id="10" name="TextBox 9"/>
           <p:cNvSpPr txBox="1"/>
           <p:nvPr/>
         </p:nvSpPr>
@@ -5745,7 +5701,7 @@
       </p:sp>
       <p:sp>
         <p:nvSpPr>
-          <p:cNvPr id="12" name="TextBox 11"/>
+          <p:cNvPr id="11" name="TextBox 10"/>
           <p:cNvSpPr txBox="1"/>
           <p:nvPr/>
         </p:nvSpPr>
@@ -5791,7 +5747,7 @@
       </p:sp>
       <p:sp>
         <p:nvSpPr>
-          <p:cNvPr id="13" name="TextBox 12"/>
+          <p:cNvPr id="12" name="TextBox 11"/>
           <p:cNvSpPr txBox="1"/>
           <p:nvPr/>
         </p:nvSpPr>
@@ -5837,7 +5793,7 @@
       </p:sp>
       <p:sp>
         <p:nvSpPr>
-          <p:cNvPr id="14" name="Rectangle 13"/>
+          <p:cNvPr id="13" name="Rectangle 12"/>
           <p:cNvSpPr/>
           <p:nvPr/>
         </p:nvSpPr>
@@ -5881,7 +5837,7 @@
       </p:sp>
       <p:sp>
         <p:nvSpPr>
-          <p:cNvPr id="15" name="TextBox 14"/>
+          <p:cNvPr id="14" name="TextBox 13"/>
           <p:cNvSpPr txBox="1"/>
           <p:nvPr/>
         </p:nvSpPr>
@@ -5980,7 +5936,7 @@
       </p:sp>
       <p:cxnSp>
         <p:nvCxnSpPr>
-          <p:cNvPr id="16" name="Connector 15"/>
+          <p:cNvPr id="15" name="Connector 14"/>
           <p:cNvCxnSpPr/>
           <p:nvPr/>
         </p:nvCxnSpPr>
@@ -5988,6 +5944,42 @@
           <a:xfrm flipV="1">
             <a:off x="6949440" y="3977639"/>
             <a:ext cx="0" cy="365761"/>
+          </a:xfrm>
+          <a:prstGeom prst="line">
+            <a:avLst/>
+          </a:prstGeom>
+          <a:ln w="8890">
+            <a:solidFill>
+              <a:srgbClr val="168581"/>
+            </a:solidFill>
+          </a:ln>
+          <a:effectLst/>
+        </p:spPr>
+        <p:style>
+          <a:lnRef idx="2">
+            <a:schemeClr val="accent1"/>
+          </a:lnRef>
+          <a:fillRef idx="0">
+            <a:schemeClr val="accent1"/>
+          </a:fillRef>
+          <a:effectRef idx="1">
+            <a:schemeClr val="accent1"/>
+          </a:effectRef>
+          <a:fontRef idx="minor">
+            <a:schemeClr val="tx1"/>
+          </a:fontRef>
+        </p:style>
+      </p:cxnSp>
+      <p:cxnSp>
+        <p:nvCxnSpPr>
+          <p:cNvPr id="16" name="Connector 15"/>
+          <p:cNvCxnSpPr/>
+          <p:nvPr/>
+        </p:nvCxnSpPr>
+        <p:spPr>
+          <a:xfrm flipV="1">
+            <a:off x="6949440" y="4115352"/>
+            <a:ext cx="285962" cy="228048"/>
           </a:xfrm>
           <a:prstGeom prst="line">
             <a:avLst/>
@@ -6021,9 +6013,9 @@
           <p:nvPr/>
         </p:nvCxnSpPr>
         <p:spPr>
-          <a:xfrm flipV="1">
-            <a:off x="6949440" y="4115352"/>
-            <a:ext cx="285962" cy="228048"/>
+          <a:xfrm>
+            <a:off x="6949440" y="4343400"/>
+            <a:ext cx="356589" cy="81389"/>
           </a:xfrm>
           <a:prstGeom prst="line">
             <a:avLst/>
@@ -6059,7 +6051,7 @@
         <p:spPr>
           <a:xfrm>
             <a:off x="6949440" y="4343400"/>
-            <a:ext cx="356589" cy="81389"/>
+            <a:ext cx="158697" cy="329538"/>
           </a:xfrm>
           <a:prstGeom prst="line">
             <a:avLst/>
@@ -6093,9 +6085,9 @@
           <p:nvPr/>
         </p:nvCxnSpPr>
         <p:spPr>
-          <a:xfrm>
-            <a:off x="6949440" y="4343400"/>
-            <a:ext cx="158697" cy="329538"/>
+          <a:xfrm flipH="1">
+            <a:off x="6790742" y="4343400"/>
+            <a:ext cx="158698" cy="329538"/>
           </a:xfrm>
           <a:prstGeom prst="line">
             <a:avLst/>
@@ -6130,8 +6122,8 @@
         </p:nvCxnSpPr>
         <p:spPr>
           <a:xfrm flipH="1">
-            <a:off x="6790742" y="4343400"/>
-            <a:ext cx="158698" cy="329538"/>
+            <a:off x="6592850" y="4343400"/>
+            <a:ext cx="356590" cy="81389"/>
           </a:xfrm>
           <a:prstGeom prst="line">
             <a:avLst/>
@@ -6165,9 +6157,9 @@
           <p:nvPr/>
         </p:nvCxnSpPr>
         <p:spPr>
-          <a:xfrm flipH="1">
-            <a:off x="6592850" y="4343400"/>
-            <a:ext cx="356590" cy="81389"/>
+          <a:xfrm flipH="1" flipV="1">
+            <a:off x="6663477" y="4115352"/>
+            <a:ext cx="285963" cy="228048"/>
           </a:xfrm>
           <a:prstGeom prst="line">
             <a:avLst/>
@@ -6194,45 +6186,9 @@
           </a:fontRef>
         </p:style>
       </p:cxnSp>
-      <p:cxnSp>
-        <p:nvCxnSpPr>
-          <p:cNvPr id="22" name="Connector 21"/>
-          <p:cNvCxnSpPr/>
-          <p:nvPr/>
-        </p:nvCxnSpPr>
-        <p:spPr>
-          <a:xfrm flipH="1" flipV="1">
-            <a:off x="6663477" y="4115352"/>
-            <a:ext cx="285963" cy="228048"/>
-          </a:xfrm>
-          <a:prstGeom prst="line">
-            <a:avLst/>
-          </a:prstGeom>
-          <a:ln w="8890">
-            <a:solidFill>
-              <a:srgbClr val="168581"/>
-            </a:solidFill>
-          </a:ln>
-          <a:effectLst/>
-        </p:spPr>
-        <p:style>
-          <a:lnRef idx="2">
-            <a:schemeClr val="accent1"/>
-          </a:lnRef>
-          <a:fillRef idx="0">
-            <a:schemeClr val="accent1"/>
-          </a:fillRef>
-          <a:effectRef idx="1">
-            <a:schemeClr val="accent1"/>
-          </a:effectRef>
-          <a:fontRef idx="minor">
-            <a:schemeClr val="tx1"/>
-          </a:fontRef>
-        </p:style>
-      </p:cxnSp>
-      <p:sp>
-        <p:nvSpPr>
-          <p:cNvPr id="23" name="Rounded Rectangle 22"/>
+      <p:sp>
+        <p:nvSpPr>
+          <p:cNvPr id="22" name="Rounded Rectangle 21"/>
           <p:cNvSpPr/>
           <p:nvPr/>
         </p:nvSpPr>
@@ -6278,7 +6234,7 @@
       </p:sp>
       <p:sp>
         <p:nvSpPr>
-          <p:cNvPr id="24" name="Rounded Rectangle 23"/>
+          <p:cNvPr id="23" name="Rounded Rectangle 22"/>
           <p:cNvSpPr/>
           <p:nvPr/>
         </p:nvSpPr>
@@ -6324,7 +6280,7 @@
       </p:sp>
       <p:sp>
         <p:nvSpPr>
-          <p:cNvPr id="25" name="Rounded Rectangle 24"/>
+          <p:cNvPr id="24" name="Rounded Rectangle 23"/>
           <p:cNvSpPr/>
           <p:nvPr/>
         </p:nvSpPr>
@@ -6370,7 +6326,7 @@
       </p:sp>
       <p:sp>
         <p:nvSpPr>
-          <p:cNvPr id="26" name="Rounded Rectangle 25"/>
+          <p:cNvPr id="25" name="Rounded Rectangle 24"/>
           <p:cNvSpPr/>
           <p:nvPr/>
         </p:nvSpPr>
@@ -6416,7 +6372,7 @@
       </p:sp>
       <p:sp>
         <p:nvSpPr>
-          <p:cNvPr id="27" name="Rounded Rectangle 26"/>
+          <p:cNvPr id="26" name="Rounded Rectangle 25"/>
           <p:cNvSpPr/>
           <p:nvPr/>
         </p:nvSpPr>
@@ -6462,7 +6418,7 @@
       </p:sp>
       <p:sp>
         <p:nvSpPr>
-          <p:cNvPr id="28" name="Rounded Rectangle 27"/>
+          <p:cNvPr id="27" name="Rounded Rectangle 26"/>
           <p:cNvSpPr/>
           <p:nvPr/>
         </p:nvSpPr>
@@ -6508,7 +6464,7 @@
       </p:sp>
       <p:sp>
         <p:nvSpPr>
-          <p:cNvPr id="29" name="Rounded Rectangle 28"/>
+          <p:cNvPr id="28" name="Rounded Rectangle 27"/>
           <p:cNvSpPr/>
           <p:nvPr/>
         </p:nvSpPr>
@@ -6554,7 +6510,7 @@
       </p:sp>
       <p:sp>
         <p:nvSpPr>
-          <p:cNvPr id="30" name="Rounded Rectangle 29"/>
+          <p:cNvPr id="29" name="Rounded Rectangle 28"/>
           <p:cNvSpPr/>
           <p:nvPr/>
         </p:nvSpPr>
@@ -6600,7 +6556,7 @@
       </p:sp>
       <p:cxnSp>
         <p:nvCxnSpPr>
-          <p:cNvPr id="31" name="Connector 30"/>
+          <p:cNvPr id="30" name="Connector 29"/>
           <p:cNvCxnSpPr/>
           <p:nvPr/>
         </p:nvCxnSpPr>
@@ -6608,6 +6564,42 @@
           <a:xfrm flipV="1">
             <a:off x="8284464" y="4736592"/>
             <a:ext cx="0" cy="137160"/>
+          </a:xfrm>
+          <a:prstGeom prst="line">
+            <a:avLst/>
+          </a:prstGeom>
+          <a:ln w="9525">
+            <a:solidFill>
+              <a:srgbClr val="D9D3C6"/>
+            </a:solidFill>
+          </a:ln>
+          <a:effectLst/>
+        </p:spPr>
+        <p:style>
+          <a:lnRef idx="2">
+            <a:schemeClr val="accent1"/>
+          </a:lnRef>
+          <a:fillRef idx="0">
+            <a:schemeClr val="accent1"/>
+          </a:fillRef>
+          <a:effectRef idx="1">
+            <a:schemeClr val="accent1"/>
+          </a:effectRef>
+          <a:fontRef idx="minor">
+            <a:schemeClr val="tx1"/>
+          </a:fontRef>
+        </p:style>
+      </p:cxnSp>
+      <p:cxnSp>
+        <p:nvCxnSpPr>
+          <p:cNvPr id="31" name="Connector 30"/>
+          <p:cNvCxnSpPr/>
+          <p:nvPr/>
+        </p:nvCxnSpPr>
+        <p:spPr>
+          <a:xfrm flipV="1">
+            <a:off x="8284464" y="4805172"/>
+            <a:ext cx="118784" cy="68580"/>
           </a:xfrm>
           <a:prstGeom prst="line">
             <a:avLst/>
@@ -6641,8 +6633,8 @@
           <p:nvPr/>
         </p:nvCxnSpPr>
         <p:spPr>
-          <a:xfrm flipV="1">
-            <a:off x="8284464" y="4805172"/>
+          <a:xfrm>
+            <a:off x="8284464" y="4873752"/>
             <a:ext cx="118784" cy="68580"/>
           </a:xfrm>
           <a:prstGeom prst="line">
@@ -6679,7 +6671,7 @@
         <p:spPr>
           <a:xfrm>
             <a:off x="8284464" y="4873752"/>
-            <a:ext cx="118784" cy="68580"/>
+            <a:ext cx="0" cy="137160"/>
           </a:xfrm>
           <a:prstGeom prst="line">
             <a:avLst/>
@@ -6713,9 +6705,9 @@
           <p:nvPr/>
         </p:nvCxnSpPr>
         <p:spPr>
-          <a:xfrm>
-            <a:off x="8284464" y="4873752"/>
-            <a:ext cx="0" cy="137160"/>
+          <a:xfrm flipH="1">
+            <a:off x="8165679" y="4873752"/>
+            <a:ext cx="118785" cy="68580"/>
           </a:xfrm>
           <a:prstGeom prst="line">
             <a:avLst/>
@@ -6749,8 +6741,8 @@
           <p:nvPr/>
         </p:nvCxnSpPr>
         <p:spPr>
-          <a:xfrm flipH="1">
-            <a:off x="8165679" y="4873752"/>
+          <a:xfrm flipH="1" flipV="1">
+            <a:off x="8165679" y="4805172"/>
             <a:ext cx="118785" cy="68580"/>
           </a:xfrm>
           <a:prstGeom prst="line">
@@ -6778,45 +6770,9 @@
           </a:fontRef>
         </p:style>
       </p:cxnSp>
-      <p:cxnSp>
-        <p:nvCxnSpPr>
-          <p:cNvPr id="36" name="Connector 35"/>
-          <p:cNvCxnSpPr/>
-          <p:nvPr/>
-        </p:nvCxnSpPr>
-        <p:spPr>
-          <a:xfrm flipH="1" flipV="1">
-            <a:off x="8165679" y="4805172"/>
-            <a:ext cx="118785" cy="68580"/>
-          </a:xfrm>
-          <a:prstGeom prst="line">
-            <a:avLst/>
-          </a:prstGeom>
-          <a:ln w="9525">
-            <a:solidFill>
-              <a:srgbClr val="D9D3C6"/>
-            </a:solidFill>
-          </a:ln>
-          <a:effectLst/>
-        </p:spPr>
-        <p:style>
-          <a:lnRef idx="2">
-            <a:schemeClr val="accent1"/>
-          </a:lnRef>
-          <a:fillRef idx="0">
-            <a:schemeClr val="accent1"/>
-          </a:fillRef>
-          <a:effectRef idx="1">
-            <a:schemeClr val="accent1"/>
-          </a:effectRef>
-          <a:fontRef idx="minor">
-            <a:schemeClr val="tx1"/>
-          </a:fontRef>
-        </p:style>
-      </p:cxnSp>
-      <p:sp>
-        <p:nvSpPr>
-          <p:cNvPr id="37" name="Rounded Rectangle 36"/>
+      <p:sp>
+        <p:nvSpPr>
+          <p:cNvPr id="36" name="Rounded Rectangle 35"/>
           <p:cNvSpPr/>
           <p:nvPr/>
         </p:nvSpPr>
@@ -6862,7 +6818,7 @@
       </p:sp>
       <p:sp>
         <p:nvSpPr>
-          <p:cNvPr id="38" name="Rounded Rectangle 37"/>
+          <p:cNvPr id="37" name="Rounded Rectangle 36"/>
           <p:cNvSpPr/>
           <p:nvPr/>
         </p:nvSpPr>
@@ -6908,7 +6864,7 @@
       </p:sp>
       <p:sp>
         <p:nvSpPr>
-          <p:cNvPr id="39" name="Rounded Rectangle 38"/>
+          <p:cNvPr id="38" name="Rounded Rectangle 37"/>
           <p:cNvSpPr/>
           <p:nvPr/>
         </p:nvSpPr>
@@ -6954,7 +6910,7 @@
       </p:sp>
       <p:sp>
         <p:nvSpPr>
-          <p:cNvPr id="40" name="Rounded Rectangle 39"/>
+          <p:cNvPr id="39" name="Rounded Rectangle 38"/>
           <p:cNvSpPr/>
           <p:nvPr/>
         </p:nvSpPr>
@@ -7000,7 +6956,7 @@
       </p:sp>
       <p:sp>
         <p:nvSpPr>
-          <p:cNvPr id="41" name="Rounded Rectangle 40"/>
+          <p:cNvPr id="40" name="Rounded Rectangle 39"/>
           <p:cNvSpPr/>
           <p:nvPr/>
         </p:nvSpPr>
@@ -7046,7 +7002,7 @@
       </p:sp>
       <p:sp>
         <p:nvSpPr>
-          <p:cNvPr id="42" name="Rounded Rectangle 41"/>
+          <p:cNvPr id="41" name="Rounded Rectangle 40"/>
           <p:cNvSpPr/>
           <p:nvPr/>
         </p:nvSpPr>
@@ -7092,7 +7048,7 @@
       </p:sp>
       <p:sp>
         <p:nvSpPr>
-          <p:cNvPr id="43" name="Rounded Rectangle 42"/>
+          <p:cNvPr id="42" name="Rounded Rectangle 41"/>
           <p:cNvSpPr/>
           <p:nvPr/>
         </p:nvSpPr>
@@ -7138,7 +7094,7 @@
       </p:sp>
       <p:sp>
         <p:nvSpPr>
-          <p:cNvPr id="44" name="TextBox 43"/>
+          <p:cNvPr id="43" name="TextBox 42"/>
           <p:cNvSpPr txBox="1"/>
           <p:nvPr/>
         </p:nvSpPr>
@@ -7184,7 +7140,7 @@
       </p:sp>
       <p:sp>
         <p:nvSpPr>
-          <p:cNvPr id="45" name="TextBox 44"/>
+          <p:cNvPr id="44" name="TextBox 43"/>
           <p:cNvSpPr txBox="1"/>
           <p:nvPr/>
         </p:nvSpPr>
@@ -7384,17 +7340,19 @@
       </p:sp>
       <p:sp>
         <p:nvSpPr>
-          <p:cNvPr id="5" name="Rectangle 4"/>
+          <p:cNvPr id="5" name="Rounded Rectangle 4"/>
           <p:cNvSpPr/>
           <p:nvPr/>
         </p:nvSpPr>
         <p:spPr>
           <a:xfrm>
-            <a:off x="566928" y="1191006"/>
-            <a:ext cx="1097280" cy="45720"/>
-          </a:xfrm>
-          <a:prstGeom prst="rect">
-            <a:avLst/>
+            <a:off x="365760" y="1517904"/>
+            <a:ext cx="384048" cy="384048"/>
+          </a:xfrm>
+          <a:prstGeom prst="roundRect">
+            <a:avLst>
+              <a:gd name="adj" fmla="val 50000"/>
+            </a:avLst>
           </a:prstGeom>
           <a:solidFill>
             <a:srgbClr val="E1542A"/>
@@ -7428,53 +7386,7 @@
       </p:sp>
       <p:sp>
         <p:nvSpPr>
-          <p:cNvPr id="6" name="Rounded Rectangle 5"/>
-          <p:cNvSpPr/>
-          <p:nvPr/>
-        </p:nvSpPr>
-        <p:spPr>
-          <a:xfrm>
-            <a:off x="365760" y="1517904"/>
-            <a:ext cx="384048" cy="384048"/>
-          </a:xfrm>
-          <a:prstGeom prst="roundRect">
-            <a:avLst>
-              <a:gd name="adj" fmla="val 50000"/>
-            </a:avLst>
-          </a:prstGeom>
-          <a:solidFill>
-            <a:srgbClr val="E1542A"/>
-          </a:solidFill>
-          <a:ln>
-            <a:noFill/>
-          </a:ln>
-          <a:effectLst/>
-        </p:spPr>
-        <p:style>
-          <a:lnRef idx="1">
-            <a:schemeClr val="accent1"/>
-          </a:lnRef>
-          <a:fillRef idx="3">
-            <a:schemeClr val="accent1"/>
-          </a:fillRef>
-          <a:effectRef idx="2">
-            <a:schemeClr val="accent1"/>
-          </a:effectRef>
-          <a:fontRef idx="minor">
-            <a:schemeClr val="lt1"/>
-          </a:fontRef>
-        </p:style>
-        <p:txBody>
-          <a:bodyPr rtlCol="0" anchor="ctr"/>
-          <a:lstStyle/>
-          <a:p>
-            <a:pPr algn="ctr"/>
-          </a:p>
-        </p:txBody>
-      </p:sp>
-      <p:sp>
-        <p:nvSpPr>
-          <p:cNvPr id="7" name="TextBox 6"/>
+          <p:cNvPr id="6" name="TextBox 5"/>
           <p:cNvSpPr txBox="1"/>
           <p:nvPr/>
         </p:nvSpPr>
@@ -7520,7 +7432,7 @@
       </p:sp>
       <p:sp>
         <p:nvSpPr>
-          <p:cNvPr id="8" name="TextBox 7"/>
+          <p:cNvPr id="7" name="TextBox 6"/>
           <p:cNvSpPr txBox="1"/>
           <p:nvPr/>
         </p:nvSpPr>
@@ -7566,7 +7478,7 @@
       </p:sp>
       <p:sp>
         <p:nvSpPr>
-          <p:cNvPr id="9" name="TextBox 8"/>
+          <p:cNvPr id="8" name="TextBox 7"/>
           <p:cNvSpPr txBox="1"/>
           <p:nvPr/>
         </p:nvSpPr>
@@ -7612,7 +7524,7 @@
       </p:sp>
       <p:sp>
         <p:nvSpPr>
-          <p:cNvPr id="10" name="Rounded Rectangle 9"/>
+          <p:cNvPr id="9" name="Rounded Rectangle 8"/>
           <p:cNvSpPr/>
           <p:nvPr/>
         </p:nvSpPr>
@@ -7658,7 +7570,7 @@
       </p:sp>
       <p:sp>
         <p:nvSpPr>
-          <p:cNvPr id="11" name="TextBox 10"/>
+          <p:cNvPr id="10" name="TextBox 9"/>
           <p:cNvSpPr txBox="1"/>
           <p:nvPr/>
         </p:nvSpPr>
@@ -7704,7 +7616,7 @@
       </p:sp>
       <p:sp>
         <p:nvSpPr>
-          <p:cNvPr id="12" name="TextBox 11"/>
+          <p:cNvPr id="11" name="TextBox 10"/>
           <p:cNvSpPr txBox="1"/>
           <p:nvPr/>
         </p:nvSpPr>
@@ -7750,7 +7662,7 @@
       </p:sp>
       <p:sp>
         <p:nvSpPr>
-          <p:cNvPr id="13" name="TextBox 12"/>
+          <p:cNvPr id="12" name="TextBox 11"/>
           <p:cNvSpPr txBox="1"/>
           <p:nvPr/>
         </p:nvSpPr>
@@ -7796,7 +7708,7 @@
       </p:sp>
       <p:sp>
         <p:nvSpPr>
-          <p:cNvPr id="14" name="Rounded Rectangle 13"/>
+          <p:cNvPr id="13" name="Rounded Rectangle 12"/>
           <p:cNvSpPr/>
           <p:nvPr/>
         </p:nvSpPr>
@@ -7842,7 +7754,7 @@
       </p:sp>
       <p:sp>
         <p:nvSpPr>
-          <p:cNvPr id="15" name="TextBox 14"/>
+          <p:cNvPr id="14" name="TextBox 13"/>
           <p:cNvSpPr txBox="1"/>
           <p:nvPr/>
         </p:nvSpPr>
@@ -7888,7 +7800,7 @@
       </p:sp>
       <p:sp>
         <p:nvSpPr>
-          <p:cNvPr id="16" name="TextBox 15"/>
+          <p:cNvPr id="15" name="TextBox 14"/>
           <p:cNvSpPr txBox="1"/>
           <p:nvPr/>
         </p:nvSpPr>
@@ -7934,7 +7846,7 @@
       </p:sp>
       <p:sp>
         <p:nvSpPr>
-          <p:cNvPr id="17" name="TextBox 16"/>
+          <p:cNvPr id="16" name="TextBox 15"/>
           <p:cNvSpPr txBox="1"/>
           <p:nvPr/>
         </p:nvSpPr>
@@ -7980,7 +7892,7 @@
       </p:sp>
       <p:sp>
         <p:nvSpPr>
-          <p:cNvPr id="18" name="Rounded Rectangle 17"/>
+          <p:cNvPr id="17" name="Rounded Rectangle 16"/>
           <p:cNvSpPr/>
           <p:nvPr/>
         </p:nvSpPr>
@@ -8026,7 +7938,7 @@
       </p:sp>
       <p:sp>
         <p:nvSpPr>
-          <p:cNvPr id="19" name="TextBox 18"/>
+          <p:cNvPr id="18" name="TextBox 17"/>
           <p:cNvSpPr txBox="1"/>
           <p:nvPr/>
         </p:nvSpPr>
@@ -8072,7 +7984,7 @@
       </p:sp>
       <p:sp>
         <p:nvSpPr>
-          <p:cNvPr id="20" name="TextBox 19"/>
+          <p:cNvPr id="19" name="TextBox 18"/>
           <p:cNvSpPr txBox="1"/>
           <p:nvPr/>
         </p:nvSpPr>
@@ -8118,7 +8030,7 @@
       </p:sp>
       <p:sp>
         <p:nvSpPr>
-          <p:cNvPr id="21" name="TextBox 20"/>
+          <p:cNvPr id="20" name="TextBox 19"/>
           <p:cNvSpPr txBox="1"/>
           <p:nvPr/>
         </p:nvSpPr>
@@ -8164,7 +8076,7 @@
       </p:sp>
       <p:sp>
         <p:nvSpPr>
-          <p:cNvPr id="22" name="Rounded Rectangle 21"/>
+          <p:cNvPr id="21" name="Rounded Rectangle 20"/>
           <p:cNvSpPr/>
           <p:nvPr/>
         </p:nvSpPr>
@@ -8210,7 +8122,7 @@
       </p:sp>
       <p:cxnSp>
         <p:nvCxnSpPr>
-          <p:cNvPr id="23" name="Connector 22"/>
+          <p:cNvPr id="22" name="Connector 21"/>
           <p:cNvCxnSpPr/>
           <p:nvPr/>
         </p:nvCxnSpPr>
@@ -8218,6 +8130,42 @@
           <a:xfrm flipV="1">
             <a:off x="7020559" y="1965960"/>
             <a:ext cx="0" cy="566928"/>
+          </a:xfrm>
+          <a:prstGeom prst="line">
+            <a:avLst/>
+          </a:prstGeom>
+          <a:ln w="10160">
+            <a:solidFill>
+              <a:srgbClr val="168581"/>
+            </a:solidFill>
+          </a:ln>
+          <a:effectLst/>
+        </p:spPr>
+        <p:style>
+          <a:lnRef idx="2">
+            <a:schemeClr val="accent1"/>
+          </a:lnRef>
+          <a:fillRef idx="0">
+            <a:schemeClr val="accent1"/>
+          </a:fillRef>
+          <a:effectRef idx="1">
+            <a:schemeClr val="accent1"/>
+          </a:effectRef>
+          <a:fontRef idx="minor">
+            <a:schemeClr val="tx1"/>
+          </a:fontRef>
+        </p:style>
+      </p:cxnSp>
+      <p:cxnSp>
+        <p:nvCxnSpPr>
+          <p:cNvPr id="23" name="Connector 22"/>
+          <p:cNvCxnSpPr/>
+          <p:nvPr/>
+        </p:nvCxnSpPr>
+        <p:spPr>
+          <a:xfrm flipV="1">
+            <a:off x="7020559" y="2179414"/>
+            <a:ext cx="443243" cy="353474"/>
           </a:xfrm>
           <a:prstGeom prst="line">
             <a:avLst/>
@@ -8251,9 +8199,9 @@
           <p:nvPr/>
         </p:nvCxnSpPr>
         <p:spPr>
-          <a:xfrm flipV="1">
-            <a:off x="7020559" y="2179414"/>
-            <a:ext cx="443243" cy="353474"/>
+          <a:xfrm>
+            <a:off x="7020559" y="2532888"/>
+            <a:ext cx="552714" cy="126153"/>
           </a:xfrm>
           <a:prstGeom prst="line">
             <a:avLst/>
@@ -8289,7 +8237,7 @@
         <p:spPr>
           <a:xfrm>
             <a:off x="7020559" y="2532888"/>
-            <a:ext cx="552714" cy="126153"/>
+            <a:ext cx="245981" cy="510784"/>
           </a:xfrm>
           <a:prstGeom prst="line">
             <a:avLst/>
@@ -8323,9 +8271,9 @@
           <p:nvPr/>
         </p:nvCxnSpPr>
         <p:spPr>
-          <a:xfrm>
-            <a:off x="7020559" y="2532888"/>
-            <a:ext cx="245981" cy="510784"/>
+          <a:xfrm flipH="1">
+            <a:off x="6774579" y="2532888"/>
+            <a:ext cx="245980" cy="510784"/>
           </a:xfrm>
           <a:prstGeom prst="line">
             <a:avLst/>
@@ -8360,8 +8308,8 @@
         </p:nvCxnSpPr>
         <p:spPr>
           <a:xfrm flipH="1">
-            <a:off x="6774579" y="2532888"/>
-            <a:ext cx="245980" cy="510784"/>
+            <a:off x="6467846" y="2532888"/>
+            <a:ext cx="552713" cy="126153"/>
           </a:xfrm>
           <a:prstGeom prst="line">
             <a:avLst/>
@@ -8395,9 +8343,9 @@
           <p:nvPr/>
         </p:nvCxnSpPr>
         <p:spPr>
-          <a:xfrm flipH="1">
-            <a:off x="6467846" y="2532888"/>
-            <a:ext cx="552713" cy="126153"/>
+          <a:xfrm flipH="1" flipV="1">
+            <a:off x="6577317" y="2179414"/>
+            <a:ext cx="443242" cy="353474"/>
           </a:xfrm>
           <a:prstGeom prst="line">
             <a:avLst/>
@@ -8424,45 +8372,9 @@
           </a:fontRef>
         </p:style>
       </p:cxnSp>
-      <p:cxnSp>
-        <p:nvCxnSpPr>
-          <p:cNvPr id="29" name="Connector 28"/>
-          <p:cNvCxnSpPr/>
-          <p:nvPr/>
-        </p:nvCxnSpPr>
-        <p:spPr>
-          <a:xfrm flipH="1" flipV="1">
-            <a:off x="6577317" y="2179414"/>
-            <a:ext cx="443242" cy="353474"/>
-          </a:xfrm>
-          <a:prstGeom prst="line">
-            <a:avLst/>
-          </a:prstGeom>
-          <a:ln w="10160">
-            <a:solidFill>
-              <a:srgbClr val="168581"/>
-            </a:solidFill>
-          </a:ln>
-          <a:effectLst/>
-        </p:spPr>
-        <p:style>
-          <a:lnRef idx="2">
-            <a:schemeClr val="accent1"/>
-          </a:lnRef>
-          <a:fillRef idx="0">
-            <a:schemeClr val="accent1"/>
-          </a:fillRef>
-          <a:effectRef idx="1">
-            <a:schemeClr val="accent1"/>
-          </a:effectRef>
-          <a:fontRef idx="minor">
-            <a:schemeClr val="tx1"/>
-          </a:fontRef>
-        </p:style>
-      </p:cxnSp>
-      <p:sp>
-        <p:nvSpPr>
-          <p:cNvPr id="30" name="Rounded Rectangle 29"/>
+      <p:sp>
+        <p:nvSpPr>
+          <p:cNvPr id="29" name="Rounded Rectangle 28"/>
           <p:cNvSpPr/>
           <p:nvPr/>
         </p:nvSpPr>
@@ -8508,7 +8420,7 @@
       </p:sp>
       <p:sp>
         <p:nvSpPr>
-          <p:cNvPr id="31" name="Rounded Rectangle 30"/>
+          <p:cNvPr id="30" name="Rounded Rectangle 29"/>
           <p:cNvSpPr/>
           <p:nvPr/>
         </p:nvSpPr>
@@ -8554,7 +8466,7 @@
       </p:sp>
       <p:sp>
         <p:nvSpPr>
-          <p:cNvPr id="32" name="Rounded Rectangle 31"/>
+          <p:cNvPr id="31" name="Rounded Rectangle 30"/>
           <p:cNvSpPr/>
           <p:nvPr/>
         </p:nvSpPr>
@@ -8600,7 +8512,7 @@
       </p:sp>
       <p:sp>
         <p:nvSpPr>
-          <p:cNvPr id="33" name="Rounded Rectangle 32"/>
+          <p:cNvPr id="32" name="Rounded Rectangle 31"/>
           <p:cNvSpPr/>
           <p:nvPr/>
         </p:nvSpPr>
@@ -8646,7 +8558,7 @@
       </p:sp>
       <p:sp>
         <p:nvSpPr>
-          <p:cNvPr id="34" name="Rounded Rectangle 33"/>
+          <p:cNvPr id="33" name="Rounded Rectangle 32"/>
           <p:cNvSpPr/>
           <p:nvPr/>
         </p:nvSpPr>
@@ -8692,7 +8604,7 @@
       </p:sp>
       <p:sp>
         <p:nvSpPr>
-          <p:cNvPr id="35" name="Rounded Rectangle 34"/>
+          <p:cNvPr id="34" name="Rounded Rectangle 33"/>
           <p:cNvSpPr/>
           <p:nvPr/>
         </p:nvSpPr>
@@ -8738,7 +8650,7 @@
       </p:sp>
       <p:sp>
         <p:nvSpPr>
-          <p:cNvPr id="36" name="Rounded Rectangle 35"/>
+          <p:cNvPr id="35" name="Rounded Rectangle 34"/>
           <p:cNvSpPr/>
           <p:nvPr/>
         </p:nvSpPr>
@@ -8784,7 +8696,7 @@
       </p:sp>
       <p:sp>
         <p:nvSpPr>
-          <p:cNvPr id="37" name="Rounded Rectangle 36"/>
+          <p:cNvPr id="36" name="Rounded Rectangle 35"/>
           <p:cNvSpPr/>
           <p:nvPr/>
         </p:nvSpPr>
@@ -8830,7 +8742,7 @@
       </p:sp>
       <p:sp>
         <p:nvSpPr>
-          <p:cNvPr id="38" name="TextBox 37"/>
+          <p:cNvPr id="37" name="TextBox 36"/>
           <p:cNvSpPr txBox="1"/>
           <p:nvPr/>
         </p:nvSpPr>
@@ -8920,7 +8832,7 @@
       </p:sp>
       <p:cxnSp>
         <p:nvCxnSpPr>
-          <p:cNvPr id="39" name="Connector 38"/>
+          <p:cNvPr id="38" name="Connector 37"/>
           <p:cNvCxnSpPr/>
           <p:nvPr/>
         </p:nvCxnSpPr>
@@ -8928,6 +8840,42 @@
           <a:xfrm flipV="1">
             <a:off x="8284464" y="4736592"/>
             <a:ext cx="0" cy="137160"/>
+          </a:xfrm>
+          <a:prstGeom prst="line">
+            <a:avLst/>
+          </a:prstGeom>
+          <a:ln w="9525">
+            <a:solidFill>
+              <a:srgbClr val="D9D3C6"/>
+            </a:solidFill>
+          </a:ln>
+          <a:effectLst/>
+        </p:spPr>
+        <p:style>
+          <a:lnRef idx="2">
+            <a:schemeClr val="accent1"/>
+          </a:lnRef>
+          <a:fillRef idx="0">
+            <a:schemeClr val="accent1"/>
+          </a:fillRef>
+          <a:effectRef idx="1">
+            <a:schemeClr val="accent1"/>
+          </a:effectRef>
+          <a:fontRef idx="minor">
+            <a:schemeClr val="tx1"/>
+          </a:fontRef>
+        </p:style>
+      </p:cxnSp>
+      <p:cxnSp>
+        <p:nvCxnSpPr>
+          <p:cNvPr id="39" name="Connector 38"/>
+          <p:cNvCxnSpPr/>
+          <p:nvPr/>
+        </p:nvCxnSpPr>
+        <p:spPr>
+          <a:xfrm flipV="1">
+            <a:off x="8284464" y="4805172"/>
+            <a:ext cx="118784" cy="68580"/>
           </a:xfrm>
           <a:prstGeom prst="line">
             <a:avLst/>
@@ -8961,8 +8909,8 @@
           <p:nvPr/>
         </p:nvCxnSpPr>
         <p:spPr>
-          <a:xfrm flipV="1">
-            <a:off x="8284464" y="4805172"/>
+          <a:xfrm>
+            <a:off x="8284464" y="4873752"/>
             <a:ext cx="118784" cy="68580"/>
           </a:xfrm>
           <a:prstGeom prst="line">
@@ -8999,7 +8947,7 @@
         <p:spPr>
           <a:xfrm>
             <a:off x="8284464" y="4873752"/>
-            <a:ext cx="118784" cy="68580"/>
+            <a:ext cx="0" cy="137160"/>
           </a:xfrm>
           <a:prstGeom prst="line">
             <a:avLst/>
@@ -9033,9 +8981,9 @@
           <p:nvPr/>
         </p:nvCxnSpPr>
         <p:spPr>
-          <a:xfrm>
-            <a:off x="8284464" y="4873752"/>
-            <a:ext cx="0" cy="137160"/>
+          <a:xfrm flipH="1">
+            <a:off x="8165679" y="4873752"/>
+            <a:ext cx="118785" cy="68580"/>
           </a:xfrm>
           <a:prstGeom prst="line">
             <a:avLst/>
@@ -9069,8 +9017,8 @@
           <p:nvPr/>
         </p:nvCxnSpPr>
         <p:spPr>
-          <a:xfrm flipH="1">
-            <a:off x="8165679" y="4873752"/>
+          <a:xfrm flipH="1" flipV="1">
+            <a:off x="8165679" y="4805172"/>
             <a:ext cx="118785" cy="68580"/>
           </a:xfrm>
           <a:prstGeom prst="line">
@@ -9098,45 +9046,9 @@
           </a:fontRef>
         </p:style>
       </p:cxnSp>
-      <p:cxnSp>
-        <p:nvCxnSpPr>
-          <p:cNvPr id="44" name="Connector 43"/>
-          <p:cNvCxnSpPr/>
-          <p:nvPr/>
-        </p:nvCxnSpPr>
-        <p:spPr>
-          <a:xfrm flipH="1" flipV="1">
-            <a:off x="8165679" y="4805172"/>
-            <a:ext cx="118785" cy="68580"/>
-          </a:xfrm>
-          <a:prstGeom prst="line">
-            <a:avLst/>
-          </a:prstGeom>
-          <a:ln w="9525">
-            <a:solidFill>
-              <a:srgbClr val="D9D3C6"/>
-            </a:solidFill>
-          </a:ln>
-          <a:effectLst/>
-        </p:spPr>
-        <p:style>
-          <a:lnRef idx="2">
-            <a:schemeClr val="accent1"/>
-          </a:lnRef>
-          <a:fillRef idx="0">
-            <a:schemeClr val="accent1"/>
-          </a:fillRef>
-          <a:effectRef idx="1">
-            <a:schemeClr val="accent1"/>
-          </a:effectRef>
-          <a:fontRef idx="minor">
-            <a:schemeClr val="tx1"/>
-          </a:fontRef>
-        </p:style>
-      </p:cxnSp>
-      <p:sp>
-        <p:nvSpPr>
-          <p:cNvPr id="45" name="Rounded Rectangle 44"/>
+      <p:sp>
+        <p:nvSpPr>
+          <p:cNvPr id="44" name="Rounded Rectangle 43"/>
           <p:cNvSpPr/>
           <p:nvPr/>
         </p:nvSpPr>
@@ -9182,7 +9094,7 @@
       </p:sp>
       <p:sp>
         <p:nvSpPr>
-          <p:cNvPr id="46" name="Rounded Rectangle 45"/>
+          <p:cNvPr id="45" name="Rounded Rectangle 44"/>
           <p:cNvSpPr/>
           <p:nvPr/>
         </p:nvSpPr>
@@ -9228,7 +9140,7 @@
       </p:sp>
       <p:sp>
         <p:nvSpPr>
-          <p:cNvPr id="47" name="Rounded Rectangle 46"/>
+          <p:cNvPr id="46" name="Rounded Rectangle 45"/>
           <p:cNvSpPr/>
           <p:nvPr/>
         </p:nvSpPr>
@@ -9274,7 +9186,7 @@
       </p:sp>
       <p:sp>
         <p:nvSpPr>
-          <p:cNvPr id="48" name="Rounded Rectangle 47"/>
+          <p:cNvPr id="47" name="Rounded Rectangle 46"/>
           <p:cNvSpPr/>
           <p:nvPr/>
         </p:nvSpPr>
@@ -9320,7 +9232,7 @@
       </p:sp>
       <p:sp>
         <p:nvSpPr>
-          <p:cNvPr id="49" name="Rounded Rectangle 48"/>
+          <p:cNvPr id="48" name="Rounded Rectangle 47"/>
           <p:cNvSpPr/>
           <p:nvPr/>
         </p:nvSpPr>
@@ -9366,7 +9278,7 @@
       </p:sp>
       <p:sp>
         <p:nvSpPr>
-          <p:cNvPr id="50" name="Rounded Rectangle 49"/>
+          <p:cNvPr id="49" name="Rounded Rectangle 48"/>
           <p:cNvSpPr/>
           <p:nvPr/>
         </p:nvSpPr>
@@ -9412,7 +9324,7 @@
       </p:sp>
       <p:sp>
         <p:nvSpPr>
-          <p:cNvPr id="51" name="Rounded Rectangle 50"/>
+          <p:cNvPr id="50" name="Rounded Rectangle 49"/>
           <p:cNvSpPr/>
           <p:nvPr/>
         </p:nvSpPr>
@@ -9458,7 +9370,7 @@
       </p:sp>
       <p:sp>
         <p:nvSpPr>
-          <p:cNvPr id="52" name="TextBox 51"/>
+          <p:cNvPr id="51" name="TextBox 50"/>
           <p:cNvSpPr txBox="1"/>
           <p:nvPr/>
         </p:nvSpPr>
@@ -9504,7 +9416,7 @@
       </p:sp>
       <p:sp>
         <p:nvSpPr>
-          <p:cNvPr id="53" name="TextBox 52"/>
+          <p:cNvPr id="52" name="TextBox 51"/>
           <p:cNvSpPr txBox="1"/>
           <p:nvPr/>
         </p:nvSpPr>
@@ -11430,51 +11342,7 @@
       </p:sp>
       <p:sp>
         <p:nvSpPr>
-          <p:cNvPr id="5" name="Rectangle 4"/>
-          <p:cNvSpPr/>
-          <p:nvPr/>
-        </p:nvSpPr>
-        <p:spPr>
-          <a:xfrm>
-            <a:off x="566928" y="1191006"/>
-            <a:ext cx="1097280" cy="45720"/>
-          </a:xfrm>
-          <a:prstGeom prst="rect">
-            <a:avLst/>
-          </a:prstGeom>
-          <a:solidFill>
-            <a:srgbClr val="E1542A"/>
-          </a:solidFill>
-          <a:ln>
-            <a:noFill/>
-          </a:ln>
-          <a:effectLst/>
-        </p:spPr>
-        <p:style>
-          <a:lnRef idx="1">
-            <a:schemeClr val="accent1"/>
-          </a:lnRef>
-          <a:fillRef idx="3">
-            <a:schemeClr val="accent1"/>
-          </a:fillRef>
-          <a:effectRef idx="2">
-            <a:schemeClr val="accent1"/>
-          </a:effectRef>
-          <a:fontRef idx="minor">
-            <a:schemeClr val="lt1"/>
-          </a:fontRef>
-        </p:style>
-        <p:txBody>
-          <a:bodyPr rtlCol="0" anchor="ctr"/>
-          <a:lstStyle/>
-          <a:p>
-            <a:pPr algn="ctr"/>
-          </a:p>
-        </p:txBody>
-      </p:sp>
-      <p:sp>
-        <p:nvSpPr>
-          <p:cNvPr id="6" name="Rounded Rectangle 5"/>
+          <p:cNvPr id="5" name="Rounded Rectangle 4"/>
           <p:cNvSpPr/>
           <p:nvPr/>
         </p:nvSpPr>
@@ -11522,7 +11390,7 @@
       </p:sp>
       <p:sp>
         <p:nvSpPr>
-          <p:cNvPr id="7" name="Rounded Rectangle 6"/>
+          <p:cNvPr id="6" name="Rounded Rectangle 5"/>
           <p:cNvSpPr/>
           <p:nvPr/>
         </p:nvSpPr>
@@ -11568,7 +11436,7 @@
       </p:sp>
       <p:pic>
         <p:nvPicPr>
-          <p:cNvPr id="8" name="Picture 7" descr="sparkles_168581.png"/>
+          <p:cNvPr id="7" name="Picture 6" descr="sparkles_168581.png"/>
           <p:cNvPicPr>
             <a:picLocks noChangeAspect="1"/>
           </p:cNvPicPr>
@@ -11592,7 +11460,7 @@
       </p:pic>
       <p:sp>
         <p:nvSpPr>
-          <p:cNvPr id="9" name="TextBox 8"/>
+          <p:cNvPr id="8" name="TextBox 7"/>
           <p:cNvSpPr txBox="1"/>
           <p:nvPr/>
         </p:nvSpPr>
@@ -11638,7 +11506,7 @@
       </p:sp>
       <p:sp>
         <p:nvSpPr>
-          <p:cNvPr id="10" name="TextBox 9"/>
+          <p:cNvPr id="9" name="TextBox 8"/>
           <p:cNvSpPr txBox="1"/>
           <p:nvPr/>
         </p:nvSpPr>
@@ -11684,7 +11552,7 @@
       </p:sp>
       <p:sp>
         <p:nvSpPr>
-          <p:cNvPr id="11" name="Rounded Rectangle 10"/>
+          <p:cNvPr id="10" name="Rounded Rectangle 9"/>
           <p:cNvSpPr/>
           <p:nvPr/>
         </p:nvSpPr>
@@ -11732,7 +11600,7 @@
       </p:sp>
       <p:sp>
         <p:nvSpPr>
-          <p:cNvPr id="12" name="Rounded Rectangle 11"/>
+          <p:cNvPr id="11" name="Rounded Rectangle 10"/>
           <p:cNvSpPr/>
           <p:nvPr/>
         </p:nvSpPr>
@@ -11778,7 +11646,7 @@
       </p:sp>
       <p:pic>
         <p:nvPicPr>
-          <p:cNvPr id="13" name="Picture 12" descr="bot_168581.png"/>
+          <p:cNvPr id="12" name="Picture 11" descr="bot_168581.png"/>
           <p:cNvPicPr>
             <a:picLocks noChangeAspect="1"/>
           </p:cNvPicPr>
@@ -11802,7 +11670,7 @@
       </p:pic>
       <p:sp>
         <p:nvSpPr>
-          <p:cNvPr id="14" name="TextBox 13"/>
+          <p:cNvPr id="13" name="TextBox 12"/>
           <p:cNvSpPr txBox="1"/>
           <p:nvPr/>
         </p:nvSpPr>
@@ -11848,7 +11716,7 @@
       </p:sp>
       <p:sp>
         <p:nvSpPr>
-          <p:cNvPr id="15" name="TextBox 14"/>
+          <p:cNvPr id="14" name="TextBox 13"/>
           <p:cNvSpPr txBox="1"/>
           <p:nvPr/>
         </p:nvSpPr>
@@ -11894,7 +11762,7 @@
       </p:sp>
       <p:sp>
         <p:nvSpPr>
-          <p:cNvPr id="16" name="Rounded Rectangle 15"/>
+          <p:cNvPr id="15" name="Rounded Rectangle 14"/>
           <p:cNvSpPr/>
           <p:nvPr/>
         </p:nvSpPr>
@@ -11942,7 +11810,7 @@
       </p:sp>
       <p:sp>
         <p:nvSpPr>
-          <p:cNvPr id="17" name="Rounded Rectangle 16"/>
+          <p:cNvPr id="16" name="Rounded Rectangle 15"/>
           <p:cNvSpPr/>
           <p:nvPr/>
         </p:nvSpPr>
@@ -11988,7 +11856,7 @@
       </p:sp>
       <p:pic>
         <p:nvPicPr>
-          <p:cNvPr id="18" name="Picture 17" descr="blocks_168581.png"/>
+          <p:cNvPr id="17" name="Picture 16" descr="blocks_168581.png"/>
           <p:cNvPicPr>
             <a:picLocks noChangeAspect="1"/>
           </p:cNvPicPr>
@@ -12012,7 +11880,7 @@
       </p:pic>
       <p:sp>
         <p:nvSpPr>
-          <p:cNvPr id="19" name="TextBox 18"/>
+          <p:cNvPr id="18" name="TextBox 17"/>
           <p:cNvSpPr txBox="1"/>
           <p:nvPr/>
         </p:nvSpPr>
@@ -12058,7 +11926,7 @@
       </p:sp>
       <p:sp>
         <p:nvSpPr>
-          <p:cNvPr id="20" name="TextBox 19"/>
+          <p:cNvPr id="19" name="TextBox 18"/>
           <p:cNvSpPr txBox="1"/>
           <p:nvPr/>
         </p:nvSpPr>
@@ -12104,7 +11972,7 @@
       </p:sp>
       <p:sp>
         <p:nvSpPr>
-          <p:cNvPr id="21" name="Rounded Rectangle 20"/>
+          <p:cNvPr id="20" name="Rounded Rectangle 19"/>
           <p:cNvSpPr/>
           <p:nvPr/>
         </p:nvSpPr>
@@ -12150,7 +12018,7 @@
       </p:sp>
       <p:sp>
         <p:nvSpPr>
-          <p:cNvPr id="22" name="Rectangle 21"/>
+          <p:cNvPr id="21" name="Rectangle 20"/>
           <p:cNvSpPr/>
           <p:nvPr/>
         </p:nvSpPr>
@@ -12194,7 +12062,7 @@
       </p:sp>
       <p:sp>
         <p:nvSpPr>
-          <p:cNvPr id="23" name="TextBox 22"/>
+          <p:cNvPr id="22" name="TextBox 21"/>
           <p:cNvSpPr txBox="1"/>
           <p:nvPr/>
         </p:nvSpPr>
@@ -12249,7 +12117,7 @@
       </p:sp>
       <p:cxnSp>
         <p:nvCxnSpPr>
-          <p:cNvPr id="24" name="Connector 23"/>
+          <p:cNvPr id="23" name="Connector 22"/>
           <p:cNvCxnSpPr/>
           <p:nvPr/>
         </p:nvCxnSpPr>
@@ -12257,6 +12125,42 @@
           <a:xfrm flipV="1">
             <a:off x="8284464" y="4736592"/>
             <a:ext cx="0" cy="137160"/>
+          </a:xfrm>
+          <a:prstGeom prst="line">
+            <a:avLst/>
+          </a:prstGeom>
+          <a:ln w="9525">
+            <a:solidFill>
+              <a:srgbClr val="D9D3C6"/>
+            </a:solidFill>
+          </a:ln>
+          <a:effectLst/>
+        </p:spPr>
+        <p:style>
+          <a:lnRef idx="2">
+            <a:schemeClr val="accent1"/>
+          </a:lnRef>
+          <a:fillRef idx="0">
+            <a:schemeClr val="accent1"/>
+          </a:fillRef>
+          <a:effectRef idx="1">
+            <a:schemeClr val="accent1"/>
+          </a:effectRef>
+          <a:fontRef idx="minor">
+            <a:schemeClr val="tx1"/>
+          </a:fontRef>
+        </p:style>
+      </p:cxnSp>
+      <p:cxnSp>
+        <p:nvCxnSpPr>
+          <p:cNvPr id="24" name="Connector 23"/>
+          <p:cNvCxnSpPr/>
+          <p:nvPr/>
+        </p:nvCxnSpPr>
+        <p:spPr>
+          <a:xfrm flipV="1">
+            <a:off x="8284464" y="4805172"/>
+            <a:ext cx="118784" cy="68580"/>
           </a:xfrm>
           <a:prstGeom prst="line">
             <a:avLst/>
@@ -12290,8 +12194,8 @@
           <p:nvPr/>
         </p:nvCxnSpPr>
         <p:spPr>
-          <a:xfrm flipV="1">
-            <a:off x="8284464" y="4805172"/>
+          <a:xfrm>
+            <a:off x="8284464" y="4873752"/>
             <a:ext cx="118784" cy="68580"/>
           </a:xfrm>
           <a:prstGeom prst="line">
@@ -12328,7 +12232,7 @@
         <p:spPr>
           <a:xfrm>
             <a:off x="8284464" y="4873752"/>
-            <a:ext cx="118784" cy="68580"/>
+            <a:ext cx="0" cy="137160"/>
           </a:xfrm>
           <a:prstGeom prst="line">
             <a:avLst/>
@@ -12362,9 +12266,9 @@
           <p:nvPr/>
         </p:nvCxnSpPr>
         <p:spPr>
-          <a:xfrm>
-            <a:off x="8284464" y="4873752"/>
-            <a:ext cx="0" cy="137160"/>
+          <a:xfrm flipH="1">
+            <a:off x="8165679" y="4873752"/>
+            <a:ext cx="118785" cy="68580"/>
           </a:xfrm>
           <a:prstGeom prst="line">
             <a:avLst/>
@@ -12398,8 +12302,8 @@
           <p:nvPr/>
         </p:nvCxnSpPr>
         <p:spPr>
-          <a:xfrm flipH="1">
-            <a:off x="8165679" y="4873752"/>
+          <a:xfrm flipH="1" flipV="1">
+            <a:off x="8165679" y="4805172"/>
             <a:ext cx="118785" cy="68580"/>
           </a:xfrm>
           <a:prstGeom prst="line">
@@ -12427,45 +12331,9 @@
           </a:fontRef>
         </p:style>
       </p:cxnSp>
-      <p:cxnSp>
-        <p:nvCxnSpPr>
-          <p:cNvPr id="29" name="Connector 28"/>
-          <p:cNvCxnSpPr/>
-          <p:nvPr/>
-        </p:nvCxnSpPr>
-        <p:spPr>
-          <a:xfrm flipH="1" flipV="1">
-            <a:off x="8165679" y="4805172"/>
-            <a:ext cx="118785" cy="68580"/>
-          </a:xfrm>
-          <a:prstGeom prst="line">
-            <a:avLst/>
-          </a:prstGeom>
-          <a:ln w="9525">
-            <a:solidFill>
-              <a:srgbClr val="D9D3C6"/>
-            </a:solidFill>
-          </a:ln>
-          <a:effectLst/>
-        </p:spPr>
-        <p:style>
-          <a:lnRef idx="2">
-            <a:schemeClr val="accent1"/>
-          </a:lnRef>
-          <a:fillRef idx="0">
-            <a:schemeClr val="accent1"/>
-          </a:fillRef>
-          <a:effectRef idx="1">
-            <a:schemeClr val="accent1"/>
-          </a:effectRef>
-          <a:fontRef idx="minor">
-            <a:schemeClr val="tx1"/>
-          </a:fontRef>
-        </p:style>
-      </p:cxnSp>
-      <p:sp>
-        <p:nvSpPr>
-          <p:cNvPr id="30" name="Rounded Rectangle 29"/>
+      <p:sp>
+        <p:nvSpPr>
+          <p:cNvPr id="29" name="Rounded Rectangle 28"/>
           <p:cNvSpPr/>
           <p:nvPr/>
         </p:nvSpPr>
@@ -12511,7 +12379,7 @@
       </p:sp>
       <p:sp>
         <p:nvSpPr>
-          <p:cNvPr id="31" name="Rounded Rectangle 30"/>
+          <p:cNvPr id="30" name="Rounded Rectangle 29"/>
           <p:cNvSpPr/>
           <p:nvPr/>
         </p:nvSpPr>
@@ -12557,7 +12425,7 @@
       </p:sp>
       <p:sp>
         <p:nvSpPr>
-          <p:cNvPr id="32" name="Rounded Rectangle 31"/>
+          <p:cNvPr id="31" name="Rounded Rectangle 30"/>
           <p:cNvSpPr/>
           <p:nvPr/>
         </p:nvSpPr>
@@ -12603,7 +12471,7 @@
       </p:sp>
       <p:sp>
         <p:nvSpPr>
-          <p:cNvPr id="33" name="Rounded Rectangle 32"/>
+          <p:cNvPr id="32" name="Rounded Rectangle 31"/>
           <p:cNvSpPr/>
           <p:nvPr/>
         </p:nvSpPr>
@@ -12649,7 +12517,7 @@
       </p:sp>
       <p:sp>
         <p:nvSpPr>
-          <p:cNvPr id="34" name="Rounded Rectangle 33"/>
+          <p:cNvPr id="33" name="Rounded Rectangle 32"/>
           <p:cNvSpPr/>
           <p:nvPr/>
         </p:nvSpPr>
@@ -12695,7 +12563,7 @@
       </p:sp>
       <p:sp>
         <p:nvSpPr>
-          <p:cNvPr id="35" name="Rounded Rectangle 34"/>
+          <p:cNvPr id="34" name="Rounded Rectangle 33"/>
           <p:cNvSpPr/>
           <p:nvPr/>
         </p:nvSpPr>
@@ -12741,7 +12609,7 @@
       </p:sp>
       <p:sp>
         <p:nvSpPr>
-          <p:cNvPr id="36" name="Rounded Rectangle 35"/>
+          <p:cNvPr id="35" name="Rounded Rectangle 34"/>
           <p:cNvSpPr/>
           <p:nvPr/>
         </p:nvSpPr>
@@ -12787,7 +12655,7 @@
       </p:sp>
       <p:sp>
         <p:nvSpPr>
-          <p:cNvPr id="37" name="TextBox 36"/>
+          <p:cNvPr id="36" name="TextBox 35"/>
           <p:cNvSpPr txBox="1"/>
           <p:nvPr/>
         </p:nvSpPr>
@@ -12833,7 +12701,7 @@
       </p:sp>
       <p:sp>
         <p:nvSpPr>
-          <p:cNvPr id="38" name="TextBox 37"/>
+          <p:cNvPr id="37" name="TextBox 36"/>
           <p:cNvSpPr txBox="1"/>
           <p:nvPr/>
         </p:nvSpPr>
@@ -13033,51 +12901,7 @@
       </p:sp>
       <p:sp>
         <p:nvSpPr>
-          <p:cNvPr id="5" name="Rectangle 4"/>
-          <p:cNvSpPr/>
-          <p:nvPr/>
-        </p:nvSpPr>
-        <p:spPr>
-          <a:xfrm>
-            <a:off x="566928" y="1191006"/>
-            <a:ext cx="1097280" cy="45720"/>
-          </a:xfrm>
-          <a:prstGeom prst="rect">
-            <a:avLst/>
-          </a:prstGeom>
-          <a:solidFill>
-            <a:srgbClr val="E1542A"/>
-          </a:solidFill>
-          <a:ln>
-            <a:noFill/>
-          </a:ln>
-          <a:effectLst/>
-        </p:spPr>
-        <p:style>
-          <a:lnRef idx="1">
-            <a:schemeClr val="accent1"/>
-          </a:lnRef>
-          <a:fillRef idx="3">
-            <a:schemeClr val="accent1"/>
-          </a:fillRef>
-          <a:effectRef idx="2">
-            <a:schemeClr val="accent1"/>
-          </a:effectRef>
-          <a:fontRef idx="minor">
-            <a:schemeClr val="lt1"/>
-          </a:fontRef>
-        </p:style>
-        <p:txBody>
-          <a:bodyPr rtlCol="0" anchor="ctr"/>
-          <a:lstStyle/>
-          <a:p>
-            <a:pPr algn="ctr"/>
-          </a:p>
-        </p:txBody>
-      </p:sp>
-      <p:sp>
-        <p:nvSpPr>
-          <p:cNvPr id="6" name="Rounded Rectangle 5"/>
+          <p:cNvPr id="5" name="Rounded Rectangle 4"/>
           <p:cNvSpPr/>
           <p:nvPr/>
         </p:nvSpPr>
@@ -13123,7 +12947,7 @@
       </p:sp>
       <p:sp>
         <p:nvSpPr>
-          <p:cNvPr id="7" name="TextBox 6"/>
+          <p:cNvPr id="6" name="TextBox 5"/>
           <p:cNvSpPr txBox="1"/>
           <p:nvPr/>
         </p:nvSpPr>
@@ -13169,7 +12993,7 @@
       </p:sp>
       <p:sp>
         <p:nvSpPr>
-          <p:cNvPr id="8" name="Rounded Rectangle 7"/>
+          <p:cNvPr id="7" name="Rounded Rectangle 6"/>
           <p:cNvSpPr/>
           <p:nvPr/>
         </p:nvSpPr>
@@ -13215,7 +13039,7 @@
       </p:sp>
       <p:sp>
         <p:nvSpPr>
-          <p:cNvPr id="9" name="TextBox 8"/>
+          <p:cNvPr id="8" name="TextBox 7"/>
           <p:cNvSpPr txBox="1"/>
           <p:nvPr/>
         </p:nvSpPr>
@@ -13261,7 +13085,7 @@
       </p:sp>
       <p:sp>
         <p:nvSpPr>
-          <p:cNvPr id="10" name="Rounded Rectangle 9"/>
+          <p:cNvPr id="9" name="Rounded Rectangle 8"/>
           <p:cNvSpPr/>
           <p:nvPr/>
         </p:nvSpPr>
@@ -13307,7 +13131,7 @@
       </p:sp>
       <p:sp>
         <p:nvSpPr>
-          <p:cNvPr id="11" name="TextBox 10"/>
+          <p:cNvPr id="10" name="TextBox 9"/>
           <p:cNvSpPr txBox="1"/>
           <p:nvPr/>
         </p:nvSpPr>
@@ -13353,7 +13177,7 @@
       </p:sp>
       <p:sp>
         <p:nvSpPr>
-          <p:cNvPr id="12" name="Rounded Rectangle 11"/>
+          <p:cNvPr id="11" name="Rounded Rectangle 10"/>
           <p:cNvSpPr/>
           <p:nvPr/>
         </p:nvSpPr>
@@ -13399,7 +13223,7 @@
       </p:sp>
       <p:sp>
         <p:nvSpPr>
-          <p:cNvPr id="13" name="TextBox 12"/>
+          <p:cNvPr id="12" name="TextBox 11"/>
           <p:cNvSpPr txBox="1"/>
           <p:nvPr/>
         </p:nvSpPr>
@@ -13445,7 +13269,7 @@
       </p:sp>
       <p:sp>
         <p:nvSpPr>
-          <p:cNvPr id="14" name="TextBox 13"/>
+          <p:cNvPr id="13" name="TextBox 12"/>
           <p:cNvSpPr txBox="1"/>
           <p:nvPr/>
         </p:nvSpPr>
@@ -13500,7 +13324,7 @@
       </p:sp>
       <p:sp>
         <p:nvSpPr>
-          <p:cNvPr id="15" name="TextBox 14"/>
+          <p:cNvPr id="14" name="TextBox 13"/>
           <p:cNvSpPr txBox="1"/>
           <p:nvPr/>
         </p:nvSpPr>
@@ -13546,7 +13370,7 @@
       </p:sp>
       <p:sp>
         <p:nvSpPr>
-          <p:cNvPr id="16" name="TextBox 15"/>
+          <p:cNvPr id="15" name="TextBox 14"/>
           <p:cNvSpPr txBox="1"/>
           <p:nvPr/>
         </p:nvSpPr>
@@ -13614,7 +13438,7 @@
       </p:sp>
       <p:sp>
         <p:nvSpPr>
-          <p:cNvPr id="17" name="TextBox 16"/>
+          <p:cNvPr id="16" name="TextBox 15"/>
           <p:cNvSpPr txBox="1"/>
           <p:nvPr/>
         </p:nvSpPr>
@@ -13660,7 +13484,7 @@
       </p:sp>
       <p:cxnSp>
         <p:nvCxnSpPr>
-          <p:cNvPr id="18" name="Connector 17"/>
+          <p:cNvPr id="17" name="Connector 16"/>
           <p:cNvCxnSpPr/>
           <p:nvPr/>
         </p:nvCxnSpPr>
@@ -13668,6 +13492,42 @@
           <a:xfrm flipV="1">
             <a:off x="8284464" y="4736592"/>
             <a:ext cx="0" cy="137160"/>
+          </a:xfrm>
+          <a:prstGeom prst="line">
+            <a:avLst/>
+          </a:prstGeom>
+          <a:ln w="9525">
+            <a:solidFill>
+              <a:srgbClr val="D9D3C6"/>
+            </a:solidFill>
+          </a:ln>
+          <a:effectLst/>
+        </p:spPr>
+        <p:style>
+          <a:lnRef idx="2">
+            <a:schemeClr val="accent1"/>
+          </a:lnRef>
+          <a:fillRef idx="0">
+            <a:schemeClr val="accent1"/>
+          </a:fillRef>
+          <a:effectRef idx="1">
+            <a:schemeClr val="accent1"/>
+          </a:effectRef>
+          <a:fontRef idx="minor">
+            <a:schemeClr val="tx1"/>
+          </a:fontRef>
+        </p:style>
+      </p:cxnSp>
+      <p:cxnSp>
+        <p:nvCxnSpPr>
+          <p:cNvPr id="18" name="Connector 17"/>
+          <p:cNvCxnSpPr/>
+          <p:nvPr/>
+        </p:nvCxnSpPr>
+        <p:spPr>
+          <a:xfrm flipV="1">
+            <a:off x="8284464" y="4805172"/>
+            <a:ext cx="118784" cy="68580"/>
           </a:xfrm>
           <a:prstGeom prst="line">
             <a:avLst/>
@@ -13701,8 +13561,8 @@
           <p:nvPr/>
         </p:nvCxnSpPr>
         <p:spPr>
-          <a:xfrm flipV="1">
-            <a:off x="8284464" y="4805172"/>
+          <a:xfrm>
+            <a:off x="8284464" y="4873752"/>
             <a:ext cx="118784" cy="68580"/>
           </a:xfrm>
           <a:prstGeom prst="line">
@@ -13739,7 +13599,7 @@
         <p:spPr>
           <a:xfrm>
             <a:off x="8284464" y="4873752"/>
-            <a:ext cx="118784" cy="68580"/>
+            <a:ext cx="0" cy="137160"/>
           </a:xfrm>
           <a:prstGeom prst="line">
             <a:avLst/>
@@ -13773,9 +13633,9 @@
           <p:nvPr/>
         </p:nvCxnSpPr>
         <p:spPr>
-          <a:xfrm>
-            <a:off x="8284464" y="4873752"/>
-            <a:ext cx="0" cy="137160"/>
+          <a:xfrm flipH="1">
+            <a:off x="8165679" y="4873752"/>
+            <a:ext cx="118785" cy="68580"/>
           </a:xfrm>
           <a:prstGeom prst="line">
             <a:avLst/>
@@ -13809,8 +13669,8 @@
           <p:nvPr/>
         </p:nvCxnSpPr>
         <p:spPr>
-          <a:xfrm flipH="1">
-            <a:off x="8165679" y="4873752"/>
+          <a:xfrm flipH="1" flipV="1">
+            <a:off x="8165679" y="4805172"/>
             <a:ext cx="118785" cy="68580"/>
           </a:xfrm>
           <a:prstGeom prst="line">
@@ -13838,45 +13698,9 @@
           </a:fontRef>
         </p:style>
       </p:cxnSp>
-      <p:cxnSp>
-        <p:nvCxnSpPr>
-          <p:cNvPr id="23" name="Connector 22"/>
-          <p:cNvCxnSpPr/>
-          <p:nvPr/>
-        </p:nvCxnSpPr>
-        <p:spPr>
-          <a:xfrm flipH="1" flipV="1">
-            <a:off x="8165679" y="4805172"/>
-            <a:ext cx="118785" cy="68580"/>
-          </a:xfrm>
-          <a:prstGeom prst="line">
-            <a:avLst/>
-          </a:prstGeom>
-          <a:ln w="9525">
-            <a:solidFill>
-              <a:srgbClr val="D9D3C6"/>
-            </a:solidFill>
-          </a:ln>
-          <a:effectLst/>
-        </p:spPr>
-        <p:style>
-          <a:lnRef idx="2">
-            <a:schemeClr val="accent1"/>
-          </a:lnRef>
-          <a:fillRef idx="0">
-            <a:schemeClr val="accent1"/>
-          </a:fillRef>
-          <a:effectRef idx="1">
-            <a:schemeClr val="accent1"/>
-          </a:effectRef>
-          <a:fontRef idx="minor">
-            <a:schemeClr val="tx1"/>
-          </a:fontRef>
-        </p:style>
-      </p:cxnSp>
-      <p:sp>
-        <p:nvSpPr>
-          <p:cNvPr id="24" name="Rounded Rectangle 23"/>
+      <p:sp>
+        <p:nvSpPr>
+          <p:cNvPr id="23" name="Rounded Rectangle 22"/>
           <p:cNvSpPr/>
           <p:nvPr/>
         </p:nvSpPr>
@@ -13922,7 +13746,7 @@
       </p:sp>
       <p:sp>
         <p:nvSpPr>
-          <p:cNvPr id="25" name="Rounded Rectangle 24"/>
+          <p:cNvPr id="24" name="Rounded Rectangle 23"/>
           <p:cNvSpPr/>
           <p:nvPr/>
         </p:nvSpPr>
@@ -13968,7 +13792,7 @@
       </p:sp>
       <p:sp>
         <p:nvSpPr>
-          <p:cNvPr id="26" name="Rounded Rectangle 25"/>
+          <p:cNvPr id="25" name="Rounded Rectangle 24"/>
           <p:cNvSpPr/>
           <p:nvPr/>
         </p:nvSpPr>
@@ -14014,7 +13838,7 @@
       </p:sp>
       <p:sp>
         <p:nvSpPr>
-          <p:cNvPr id="27" name="Rounded Rectangle 26"/>
+          <p:cNvPr id="26" name="Rounded Rectangle 25"/>
           <p:cNvSpPr/>
           <p:nvPr/>
         </p:nvSpPr>
@@ -14060,7 +13884,7 @@
       </p:sp>
       <p:sp>
         <p:nvSpPr>
-          <p:cNvPr id="28" name="Rounded Rectangle 27"/>
+          <p:cNvPr id="27" name="Rounded Rectangle 26"/>
           <p:cNvSpPr/>
           <p:nvPr/>
         </p:nvSpPr>
@@ -14106,7 +13930,7 @@
       </p:sp>
       <p:sp>
         <p:nvSpPr>
-          <p:cNvPr id="29" name="Rounded Rectangle 28"/>
+          <p:cNvPr id="28" name="Rounded Rectangle 27"/>
           <p:cNvSpPr/>
           <p:nvPr/>
         </p:nvSpPr>
@@ -14152,7 +13976,7 @@
       </p:sp>
       <p:sp>
         <p:nvSpPr>
-          <p:cNvPr id="30" name="Rounded Rectangle 29"/>
+          <p:cNvPr id="29" name="Rounded Rectangle 28"/>
           <p:cNvSpPr/>
           <p:nvPr/>
         </p:nvSpPr>
@@ -14198,7 +14022,7 @@
       </p:sp>
       <p:sp>
         <p:nvSpPr>
-          <p:cNvPr id="31" name="TextBox 30"/>
+          <p:cNvPr id="30" name="TextBox 29"/>
           <p:cNvSpPr txBox="1"/>
           <p:nvPr/>
         </p:nvSpPr>
@@ -14244,7 +14068,7 @@
       </p:sp>
       <p:sp>
         <p:nvSpPr>
-          <p:cNvPr id="32" name="TextBox 31"/>
+          <p:cNvPr id="31" name="TextBox 30"/>
           <p:cNvSpPr txBox="1"/>
           <p:nvPr/>
         </p:nvSpPr>
@@ -14442,53 +14266,9 @@
           </a:p>
         </p:txBody>
       </p:sp>
-      <p:sp>
-        <p:nvSpPr>
-          <p:cNvPr id="5" name="Rectangle 4"/>
-          <p:cNvSpPr/>
-          <p:nvPr/>
-        </p:nvSpPr>
-        <p:spPr>
-          <a:xfrm>
-            <a:off x="566928" y="1126998"/>
-            <a:ext cx="1097280" cy="45720"/>
-          </a:xfrm>
-          <a:prstGeom prst="rect">
-            <a:avLst/>
-          </a:prstGeom>
-          <a:solidFill>
-            <a:srgbClr val="E1542A"/>
-          </a:solidFill>
-          <a:ln>
-            <a:noFill/>
-          </a:ln>
-          <a:effectLst/>
-        </p:spPr>
-        <p:style>
-          <a:lnRef idx="1">
-            <a:schemeClr val="accent1"/>
-          </a:lnRef>
-          <a:fillRef idx="3">
-            <a:schemeClr val="accent1"/>
-          </a:fillRef>
-          <a:effectRef idx="2">
-            <a:schemeClr val="accent1"/>
-          </a:effectRef>
-          <a:fontRef idx="minor">
-            <a:schemeClr val="lt1"/>
-          </a:fontRef>
-        </p:style>
-        <p:txBody>
-          <a:bodyPr rtlCol="0" anchor="ctr"/>
-          <a:lstStyle/>
-          <a:p>
-            <a:pPr algn="ctr"/>
-          </a:p>
-        </p:txBody>
-      </p:sp>
       <p:cxnSp>
         <p:nvCxnSpPr>
-          <p:cNvPr id="6" name="Connector 5"/>
+          <p:cNvPr id="5" name="Connector 4"/>
           <p:cNvCxnSpPr/>
           <p:nvPr/>
         </p:nvCxnSpPr>
@@ -14525,7 +14305,7 @@
       </p:cxnSp>
       <p:cxnSp>
         <p:nvCxnSpPr>
-          <p:cNvPr id="7" name="Connector 6"/>
+          <p:cNvPr id="6" name="Connector 5"/>
           <p:cNvCxnSpPr/>
           <p:nvPr/>
         </p:nvCxnSpPr>
@@ -14562,7 +14342,7 @@
       </p:cxnSp>
       <p:cxnSp>
         <p:nvCxnSpPr>
-          <p:cNvPr id="8" name="Connector 7"/>
+          <p:cNvPr id="7" name="Connector 6"/>
           <p:cNvCxnSpPr/>
           <p:nvPr/>
         </p:nvCxnSpPr>
@@ -14599,7 +14379,7 @@
       </p:cxnSp>
       <p:cxnSp>
         <p:nvCxnSpPr>
-          <p:cNvPr id="9" name="Connector 8"/>
+          <p:cNvPr id="8" name="Connector 7"/>
           <p:cNvCxnSpPr/>
           <p:nvPr/>
         </p:nvCxnSpPr>
@@ -14636,7 +14416,7 @@
       </p:cxnSp>
       <p:cxnSp>
         <p:nvCxnSpPr>
-          <p:cNvPr id="10" name="Connector 9"/>
+          <p:cNvPr id="9" name="Connector 8"/>
           <p:cNvCxnSpPr/>
           <p:nvPr/>
         </p:nvCxnSpPr>
@@ -14673,7 +14453,7 @@
       </p:cxnSp>
       <p:cxnSp>
         <p:nvCxnSpPr>
-          <p:cNvPr id="11" name="Connector 10"/>
+          <p:cNvPr id="10" name="Connector 9"/>
           <p:cNvCxnSpPr/>
           <p:nvPr/>
         </p:nvCxnSpPr>
@@ -14710,7 +14490,7 @@
       </p:cxnSp>
       <p:sp>
         <p:nvSpPr>
-          <p:cNvPr id="12" name="Rounded Rectangle 11"/>
+          <p:cNvPr id="11" name="Rounded Rectangle 10"/>
           <p:cNvSpPr/>
           <p:nvPr/>
         </p:nvSpPr>
@@ -14756,7 +14536,7 @@
       </p:sp>
       <p:sp>
         <p:nvSpPr>
-          <p:cNvPr id="13" name="TextBox 12"/>
+          <p:cNvPr id="12" name="TextBox 11"/>
           <p:cNvSpPr txBox="1"/>
           <p:nvPr/>
         </p:nvSpPr>
@@ -14824,7 +14604,7 @@
       </p:sp>
       <p:sp>
         <p:nvSpPr>
-          <p:cNvPr id="14" name="Rounded Rectangle 13"/>
+          <p:cNvPr id="13" name="Rounded Rectangle 12"/>
           <p:cNvSpPr/>
           <p:nvPr/>
         </p:nvSpPr>
@@ -14870,7 +14650,7 @@
       </p:sp>
       <p:sp>
         <p:nvSpPr>
-          <p:cNvPr id="15" name="TextBox 14"/>
+          <p:cNvPr id="14" name="TextBox 13"/>
           <p:cNvSpPr txBox="1"/>
           <p:nvPr/>
         </p:nvSpPr>
@@ -14938,7 +14718,7 @@
       </p:sp>
       <p:sp>
         <p:nvSpPr>
-          <p:cNvPr id="16" name="Rounded Rectangle 15"/>
+          <p:cNvPr id="15" name="Rounded Rectangle 14"/>
           <p:cNvSpPr/>
           <p:nvPr/>
         </p:nvSpPr>
@@ -14984,7 +14764,7 @@
       </p:sp>
       <p:sp>
         <p:nvSpPr>
-          <p:cNvPr id="17" name="TextBox 16"/>
+          <p:cNvPr id="16" name="TextBox 15"/>
           <p:cNvSpPr txBox="1"/>
           <p:nvPr/>
         </p:nvSpPr>
@@ -15052,7 +14832,7 @@
       </p:sp>
       <p:sp>
         <p:nvSpPr>
-          <p:cNvPr id="18" name="Rounded Rectangle 17"/>
+          <p:cNvPr id="17" name="Rounded Rectangle 16"/>
           <p:cNvSpPr/>
           <p:nvPr/>
         </p:nvSpPr>
@@ -15098,7 +14878,7 @@
       </p:sp>
       <p:sp>
         <p:nvSpPr>
-          <p:cNvPr id="19" name="TextBox 18"/>
+          <p:cNvPr id="18" name="TextBox 17"/>
           <p:cNvSpPr txBox="1"/>
           <p:nvPr/>
         </p:nvSpPr>
@@ -15166,7 +14946,7 @@
       </p:sp>
       <p:sp>
         <p:nvSpPr>
-          <p:cNvPr id="20" name="Rounded Rectangle 19"/>
+          <p:cNvPr id="19" name="Rounded Rectangle 18"/>
           <p:cNvSpPr/>
           <p:nvPr/>
         </p:nvSpPr>
@@ -15212,7 +14992,7 @@
       </p:sp>
       <p:sp>
         <p:nvSpPr>
-          <p:cNvPr id="21" name="TextBox 20"/>
+          <p:cNvPr id="20" name="TextBox 19"/>
           <p:cNvSpPr txBox="1"/>
           <p:nvPr/>
         </p:nvSpPr>
@@ -15280,7 +15060,7 @@
       </p:sp>
       <p:sp>
         <p:nvSpPr>
-          <p:cNvPr id="22" name="Rounded Rectangle 21"/>
+          <p:cNvPr id="21" name="Rounded Rectangle 20"/>
           <p:cNvSpPr/>
           <p:nvPr/>
         </p:nvSpPr>
@@ -15326,7 +15106,7 @@
       </p:sp>
       <p:sp>
         <p:nvSpPr>
-          <p:cNvPr id="23" name="TextBox 22"/>
+          <p:cNvPr id="22" name="TextBox 21"/>
           <p:cNvSpPr txBox="1"/>
           <p:nvPr/>
         </p:nvSpPr>
@@ -15394,7 +15174,7 @@
       </p:sp>
       <p:sp>
         <p:nvSpPr>
-          <p:cNvPr id="24" name="Rounded Rectangle 23"/>
+          <p:cNvPr id="23" name="Rounded Rectangle 22"/>
           <p:cNvSpPr/>
           <p:nvPr/>
         </p:nvSpPr>
@@ -15440,7 +15220,7 @@
       </p:sp>
       <p:sp>
         <p:nvSpPr>
-          <p:cNvPr id="25" name="TextBox 24"/>
+          <p:cNvPr id="24" name="TextBox 23"/>
           <p:cNvSpPr txBox="1"/>
           <p:nvPr/>
         </p:nvSpPr>
@@ -15486,7 +15266,7 @@
       </p:sp>
       <p:sp>
         <p:nvSpPr>
-          <p:cNvPr id="26" name="TextBox 25"/>
+          <p:cNvPr id="25" name="TextBox 24"/>
           <p:cNvSpPr txBox="1"/>
           <p:nvPr/>
         </p:nvSpPr>
@@ -15695,51 +15475,7 @@
       </p:sp>
       <p:sp>
         <p:nvSpPr>
-          <p:cNvPr id="5" name="Rectangle 4"/>
-          <p:cNvSpPr/>
-          <p:nvPr/>
-        </p:nvSpPr>
-        <p:spPr>
-          <a:xfrm>
-            <a:off x="566928" y="1191006"/>
-            <a:ext cx="1097280" cy="45720"/>
-          </a:xfrm>
-          <a:prstGeom prst="rect">
-            <a:avLst/>
-          </a:prstGeom>
-          <a:solidFill>
-            <a:srgbClr val="E1542A"/>
-          </a:solidFill>
-          <a:ln>
-            <a:noFill/>
-          </a:ln>
-          <a:effectLst/>
-        </p:spPr>
-        <p:style>
-          <a:lnRef idx="1">
-            <a:schemeClr val="accent1"/>
-          </a:lnRef>
-          <a:fillRef idx="3">
-            <a:schemeClr val="accent1"/>
-          </a:fillRef>
-          <a:effectRef idx="2">
-            <a:schemeClr val="accent1"/>
-          </a:effectRef>
-          <a:fontRef idx="minor">
-            <a:schemeClr val="lt1"/>
-          </a:fontRef>
-        </p:style>
-        <p:txBody>
-          <a:bodyPr rtlCol="0" anchor="ctr"/>
-          <a:lstStyle/>
-          <a:p>
-            <a:pPr algn="ctr"/>
-          </a:p>
-        </p:txBody>
-      </p:sp>
-      <p:sp>
-        <p:nvSpPr>
-          <p:cNvPr id="6" name="TextBox 5"/>
+          <p:cNvPr id="5" name="TextBox 4"/>
           <p:cNvSpPr txBox="1"/>
           <p:nvPr/>
         </p:nvSpPr>
@@ -15785,7 +15521,7 @@
       </p:sp>
       <p:sp>
         <p:nvSpPr>
-          <p:cNvPr id="7" name="Rounded Rectangle 6"/>
+          <p:cNvPr id="6" name="Rounded Rectangle 5"/>
           <p:cNvSpPr/>
           <p:nvPr/>
         </p:nvSpPr>
@@ -15831,7 +15567,7 @@
       </p:sp>
       <p:sp>
         <p:nvSpPr>
-          <p:cNvPr id="8" name="TextBox 7"/>
+          <p:cNvPr id="7" name="TextBox 6"/>
           <p:cNvSpPr txBox="1"/>
           <p:nvPr/>
         </p:nvSpPr>
@@ -15899,7 +15635,7 @@
       </p:sp>
       <p:sp>
         <p:nvSpPr>
-          <p:cNvPr id="9" name="Rounded Rectangle 8"/>
+          <p:cNvPr id="8" name="Rounded Rectangle 7"/>
           <p:cNvSpPr/>
           <p:nvPr/>
         </p:nvSpPr>
@@ -15945,7 +15681,7 @@
       </p:sp>
       <p:sp>
         <p:nvSpPr>
-          <p:cNvPr id="10" name="TextBox 9"/>
+          <p:cNvPr id="9" name="TextBox 8"/>
           <p:cNvSpPr txBox="1"/>
           <p:nvPr/>
         </p:nvSpPr>
@@ -16013,7 +15749,7 @@
       </p:sp>
       <p:cxnSp>
         <p:nvCxnSpPr>
-          <p:cNvPr id="11" name="Connector 10"/>
+          <p:cNvPr id="10" name="Connector 9"/>
           <p:cNvCxnSpPr/>
           <p:nvPr/>
         </p:nvCxnSpPr>
@@ -16050,7 +15786,7 @@
       </p:cxnSp>
       <p:sp>
         <p:nvSpPr>
-          <p:cNvPr id="12" name="Rounded Rectangle 11"/>
+          <p:cNvPr id="11" name="Rounded Rectangle 10"/>
           <p:cNvSpPr/>
           <p:nvPr/>
         </p:nvSpPr>
@@ -16096,7 +15832,7 @@
       </p:sp>
       <p:sp>
         <p:nvSpPr>
-          <p:cNvPr id="13" name="TextBox 12"/>
+          <p:cNvPr id="12" name="TextBox 11"/>
           <p:cNvSpPr txBox="1"/>
           <p:nvPr/>
         </p:nvSpPr>
@@ -16164,7 +15900,7 @@
       </p:sp>
       <p:cxnSp>
         <p:nvCxnSpPr>
-          <p:cNvPr id="14" name="Connector 13"/>
+          <p:cNvPr id="13" name="Connector 12"/>
           <p:cNvCxnSpPr/>
           <p:nvPr/>
         </p:nvCxnSpPr>
@@ -16201,7 +15937,7 @@
       </p:cxnSp>
       <p:sp>
         <p:nvSpPr>
-          <p:cNvPr id="15" name="Rounded Rectangle 14"/>
+          <p:cNvPr id="14" name="Rounded Rectangle 13"/>
           <p:cNvSpPr/>
           <p:nvPr/>
         </p:nvSpPr>
@@ -16245,7 +15981,7 @@
       </p:sp>
       <p:sp>
         <p:nvSpPr>
-          <p:cNvPr id="16" name="TextBox 15"/>
+          <p:cNvPr id="15" name="TextBox 14"/>
           <p:cNvSpPr txBox="1"/>
           <p:nvPr/>
         </p:nvSpPr>
@@ -16313,7 +16049,7 @@
       </p:sp>
       <p:cxnSp>
         <p:nvCxnSpPr>
-          <p:cNvPr id="17" name="Connector 16"/>
+          <p:cNvPr id="16" name="Connector 15"/>
           <p:cNvCxnSpPr/>
           <p:nvPr/>
         </p:nvCxnSpPr>
@@ -16350,7 +16086,7 @@
       </p:cxnSp>
       <p:sp>
         <p:nvSpPr>
-          <p:cNvPr id="18" name="Rounded Rectangle 17"/>
+          <p:cNvPr id="17" name="Rounded Rectangle 16"/>
           <p:cNvSpPr/>
           <p:nvPr/>
         </p:nvSpPr>
@@ -16396,7 +16132,7 @@
       </p:sp>
       <p:sp>
         <p:nvSpPr>
-          <p:cNvPr id="19" name="TextBox 18"/>
+          <p:cNvPr id="18" name="TextBox 17"/>
           <p:cNvSpPr txBox="1"/>
           <p:nvPr/>
         </p:nvSpPr>
@@ -16464,7 +16200,7 @@
       </p:sp>
       <p:cxnSp>
         <p:nvCxnSpPr>
-          <p:cNvPr id="20" name="Connector 19"/>
+          <p:cNvPr id="19" name="Connector 18"/>
           <p:cNvCxnSpPr/>
           <p:nvPr/>
         </p:nvCxnSpPr>
@@ -16501,7 +16237,7 @@
       </p:cxnSp>
       <p:cxnSp>
         <p:nvCxnSpPr>
-          <p:cNvPr id="21" name="Connector 20"/>
+          <p:cNvPr id="20" name="Connector 19"/>
           <p:cNvCxnSpPr/>
           <p:nvPr/>
         </p:nvCxnSpPr>
@@ -16538,7 +16274,7 @@
       </p:cxnSp>
       <p:cxnSp>
         <p:nvCxnSpPr>
-          <p:cNvPr id="22" name="Connector 21"/>
+          <p:cNvPr id="21" name="Connector 20"/>
           <p:cNvCxnSpPr/>
           <p:nvPr/>
         </p:nvCxnSpPr>
@@ -16575,7 +16311,7 @@
       </p:cxnSp>
       <p:cxnSp>
         <p:nvCxnSpPr>
-          <p:cNvPr id="23" name="Connector 22"/>
+          <p:cNvPr id="22" name="Connector 21"/>
           <p:cNvCxnSpPr/>
           <p:nvPr/>
         </p:nvCxnSpPr>
@@ -16613,7 +16349,7 @@
       </p:cxnSp>
       <p:sp>
         <p:nvSpPr>
-          <p:cNvPr id="24" name="TextBox 23"/>
+          <p:cNvPr id="23" name="TextBox 22"/>
           <p:cNvSpPr txBox="1"/>
           <p:nvPr/>
         </p:nvSpPr>
@@ -16659,7 +16395,7 @@
       </p:sp>
       <p:sp>
         <p:nvSpPr>
-          <p:cNvPr id="25" name="Rounded Rectangle 24"/>
+          <p:cNvPr id="24" name="Rounded Rectangle 23"/>
           <p:cNvSpPr/>
           <p:nvPr/>
         </p:nvSpPr>
@@ -16705,7 +16441,7 @@
       </p:sp>
       <p:sp>
         <p:nvSpPr>
-          <p:cNvPr id="26" name="Rectangle 25"/>
+          <p:cNvPr id="25" name="Rectangle 24"/>
           <p:cNvSpPr/>
           <p:nvPr/>
         </p:nvSpPr>
@@ -16749,7 +16485,7 @@
       </p:sp>
       <p:sp>
         <p:nvSpPr>
-          <p:cNvPr id="27" name="TextBox 26"/>
+          <p:cNvPr id="26" name="TextBox 25"/>
           <p:cNvSpPr txBox="1"/>
           <p:nvPr/>
         </p:nvSpPr>
@@ -16804,7 +16540,7 @@
       </p:sp>
       <p:cxnSp>
         <p:nvCxnSpPr>
-          <p:cNvPr id="28" name="Connector 27"/>
+          <p:cNvPr id="27" name="Connector 26"/>
           <p:cNvCxnSpPr/>
           <p:nvPr/>
         </p:nvCxnSpPr>
@@ -16812,6 +16548,42 @@
           <a:xfrm flipV="1">
             <a:off x="8284464" y="4736592"/>
             <a:ext cx="0" cy="137160"/>
+          </a:xfrm>
+          <a:prstGeom prst="line">
+            <a:avLst/>
+          </a:prstGeom>
+          <a:ln w="9525">
+            <a:solidFill>
+              <a:srgbClr val="D9D3C6"/>
+            </a:solidFill>
+          </a:ln>
+          <a:effectLst/>
+        </p:spPr>
+        <p:style>
+          <a:lnRef idx="2">
+            <a:schemeClr val="accent1"/>
+          </a:lnRef>
+          <a:fillRef idx="0">
+            <a:schemeClr val="accent1"/>
+          </a:fillRef>
+          <a:effectRef idx="1">
+            <a:schemeClr val="accent1"/>
+          </a:effectRef>
+          <a:fontRef idx="minor">
+            <a:schemeClr val="tx1"/>
+          </a:fontRef>
+        </p:style>
+      </p:cxnSp>
+      <p:cxnSp>
+        <p:nvCxnSpPr>
+          <p:cNvPr id="28" name="Connector 27"/>
+          <p:cNvCxnSpPr/>
+          <p:nvPr/>
+        </p:nvCxnSpPr>
+        <p:spPr>
+          <a:xfrm flipV="1">
+            <a:off x="8284464" y="4805172"/>
+            <a:ext cx="118784" cy="68580"/>
           </a:xfrm>
           <a:prstGeom prst="line">
             <a:avLst/>
@@ -16845,8 +16617,8 @@
           <p:nvPr/>
         </p:nvCxnSpPr>
         <p:spPr>
-          <a:xfrm flipV="1">
-            <a:off x="8284464" y="4805172"/>
+          <a:xfrm>
+            <a:off x="8284464" y="4873752"/>
             <a:ext cx="118784" cy="68580"/>
           </a:xfrm>
           <a:prstGeom prst="line">
@@ -16883,7 +16655,7 @@
         <p:spPr>
           <a:xfrm>
             <a:off x="8284464" y="4873752"/>
-            <a:ext cx="118784" cy="68580"/>
+            <a:ext cx="0" cy="137160"/>
           </a:xfrm>
           <a:prstGeom prst="line">
             <a:avLst/>
@@ -16917,9 +16689,9 @@
           <p:nvPr/>
         </p:nvCxnSpPr>
         <p:spPr>
-          <a:xfrm>
-            <a:off x="8284464" y="4873752"/>
-            <a:ext cx="0" cy="137160"/>
+          <a:xfrm flipH="1">
+            <a:off x="8165679" y="4873752"/>
+            <a:ext cx="118785" cy="68580"/>
           </a:xfrm>
           <a:prstGeom prst="line">
             <a:avLst/>
@@ -16953,8 +16725,8 @@
           <p:nvPr/>
         </p:nvCxnSpPr>
         <p:spPr>
-          <a:xfrm flipH="1">
-            <a:off x="8165679" y="4873752"/>
+          <a:xfrm flipH="1" flipV="1">
+            <a:off x="8165679" y="4805172"/>
             <a:ext cx="118785" cy="68580"/>
           </a:xfrm>
           <a:prstGeom prst="line">
@@ -16982,45 +16754,9 @@
           </a:fontRef>
         </p:style>
       </p:cxnSp>
-      <p:cxnSp>
-        <p:nvCxnSpPr>
-          <p:cNvPr id="33" name="Connector 32"/>
-          <p:cNvCxnSpPr/>
-          <p:nvPr/>
-        </p:nvCxnSpPr>
-        <p:spPr>
-          <a:xfrm flipH="1" flipV="1">
-            <a:off x="8165679" y="4805172"/>
-            <a:ext cx="118785" cy="68580"/>
-          </a:xfrm>
-          <a:prstGeom prst="line">
-            <a:avLst/>
-          </a:prstGeom>
-          <a:ln w="9525">
-            <a:solidFill>
-              <a:srgbClr val="D9D3C6"/>
-            </a:solidFill>
-          </a:ln>
-          <a:effectLst/>
-        </p:spPr>
-        <p:style>
-          <a:lnRef idx="2">
-            <a:schemeClr val="accent1"/>
-          </a:lnRef>
-          <a:fillRef idx="0">
-            <a:schemeClr val="accent1"/>
-          </a:fillRef>
-          <a:effectRef idx="1">
-            <a:schemeClr val="accent1"/>
-          </a:effectRef>
-          <a:fontRef idx="minor">
-            <a:schemeClr val="tx1"/>
-          </a:fontRef>
-        </p:style>
-      </p:cxnSp>
-      <p:sp>
-        <p:nvSpPr>
-          <p:cNvPr id="34" name="Rounded Rectangle 33"/>
+      <p:sp>
+        <p:nvSpPr>
+          <p:cNvPr id="33" name="Rounded Rectangle 32"/>
           <p:cNvSpPr/>
           <p:nvPr/>
         </p:nvSpPr>
@@ -17066,7 +16802,7 @@
       </p:sp>
       <p:sp>
         <p:nvSpPr>
-          <p:cNvPr id="35" name="Rounded Rectangle 34"/>
+          <p:cNvPr id="34" name="Rounded Rectangle 33"/>
           <p:cNvSpPr/>
           <p:nvPr/>
         </p:nvSpPr>
@@ -17112,7 +16848,7 @@
       </p:sp>
       <p:sp>
         <p:nvSpPr>
-          <p:cNvPr id="36" name="Rounded Rectangle 35"/>
+          <p:cNvPr id="35" name="Rounded Rectangle 34"/>
           <p:cNvSpPr/>
           <p:nvPr/>
         </p:nvSpPr>
@@ -17158,7 +16894,7 @@
       </p:sp>
       <p:sp>
         <p:nvSpPr>
-          <p:cNvPr id="37" name="Rounded Rectangle 36"/>
+          <p:cNvPr id="36" name="Rounded Rectangle 35"/>
           <p:cNvSpPr/>
           <p:nvPr/>
         </p:nvSpPr>
@@ -17204,7 +16940,7 @@
       </p:sp>
       <p:sp>
         <p:nvSpPr>
-          <p:cNvPr id="38" name="Rounded Rectangle 37"/>
+          <p:cNvPr id="37" name="Rounded Rectangle 36"/>
           <p:cNvSpPr/>
           <p:nvPr/>
         </p:nvSpPr>
@@ -17250,7 +16986,7 @@
       </p:sp>
       <p:sp>
         <p:nvSpPr>
-          <p:cNvPr id="39" name="Rounded Rectangle 38"/>
+          <p:cNvPr id="38" name="Rounded Rectangle 37"/>
           <p:cNvSpPr/>
           <p:nvPr/>
         </p:nvSpPr>
@@ -17296,7 +17032,7 @@
       </p:sp>
       <p:sp>
         <p:nvSpPr>
-          <p:cNvPr id="40" name="Rounded Rectangle 39"/>
+          <p:cNvPr id="39" name="Rounded Rectangle 38"/>
           <p:cNvSpPr/>
           <p:nvPr/>
         </p:nvSpPr>
@@ -17342,7 +17078,7 @@
       </p:sp>
       <p:sp>
         <p:nvSpPr>
-          <p:cNvPr id="41" name="TextBox 40"/>
+          <p:cNvPr id="40" name="TextBox 39"/>
           <p:cNvSpPr txBox="1"/>
           <p:nvPr/>
         </p:nvSpPr>
@@ -17388,7 +17124,7 @@
       </p:sp>
       <p:sp>
         <p:nvSpPr>
-          <p:cNvPr id="42" name="TextBox 41"/>
+          <p:cNvPr id="41" name="TextBox 40"/>
           <p:cNvSpPr txBox="1"/>
           <p:nvPr/>
         </p:nvSpPr>
@@ -17588,14 +17324,60 @@
       </p:sp>
       <p:sp>
         <p:nvSpPr>
-          <p:cNvPr id="5" name="Rectangle 4"/>
+          <p:cNvPr id="5" name="Rounded Rectangle 4"/>
           <p:cNvSpPr/>
           <p:nvPr/>
         </p:nvSpPr>
         <p:spPr>
           <a:xfrm>
-            <a:off x="566928" y="1191006"/>
-            <a:ext cx="1097280" cy="45720"/>
+            <a:off x="548640" y="4050791"/>
+            <a:ext cx="8046720" cy="498347"/>
+          </a:xfrm>
+          <a:prstGeom prst="roundRect">
+            <a:avLst>
+              <a:gd name="adj" fmla="val 8000"/>
+            </a:avLst>
+          </a:prstGeom>
+          <a:solidFill>
+            <a:srgbClr val="EAF3FA"/>
+          </a:solidFill>
+          <a:ln>
+            <a:noFill/>
+          </a:ln>
+          <a:effectLst/>
+        </p:spPr>
+        <p:style>
+          <a:lnRef idx="1">
+            <a:schemeClr val="accent1"/>
+          </a:lnRef>
+          <a:fillRef idx="3">
+            <a:schemeClr val="accent1"/>
+          </a:fillRef>
+          <a:effectRef idx="2">
+            <a:schemeClr val="accent1"/>
+          </a:effectRef>
+          <a:fontRef idx="minor">
+            <a:schemeClr val="lt1"/>
+          </a:fontRef>
+        </p:style>
+        <p:txBody>
+          <a:bodyPr rtlCol="0" anchor="ctr"/>
+          <a:lstStyle/>
+          <a:p>
+            <a:pPr algn="ctr"/>
+          </a:p>
+        </p:txBody>
+      </p:sp>
+      <p:sp>
+        <p:nvSpPr>
+          <p:cNvPr id="6" name="Rectangle 5"/>
+          <p:cNvSpPr/>
+          <p:nvPr/>
+        </p:nvSpPr>
+        <p:spPr>
+          <a:xfrm>
+            <a:off x="548640" y="4090659"/>
+            <a:ext cx="64008" cy="418612"/>
           </a:xfrm>
           <a:prstGeom prst="rect">
             <a:avLst/>
@@ -17632,97 +17414,7 @@
       </p:sp>
       <p:sp>
         <p:nvSpPr>
-          <p:cNvPr id="6" name="Rounded Rectangle 5"/>
-          <p:cNvSpPr/>
-          <p:nvPr/>
-        </p:nvSpPr>
-        <p:spPr>
-          <a:xfrm>
-            <a:off x="548640" y="4050791"/>
-            <a:ext cx="8046720" cy="498347"/>
-          </a:xfrm>
-          <a:prstGeom prst="roundRect">
-            <a:avLst>
-              <a:gd name="adj" fmla="val 8000"/>
-            </a:avLst>
-          </a:prstGeom>
-          <a:solidFill>
-            <a:srgbClr val="EAF3FA"/>
-          </a:solidFill>
-          <a:ln>
-            <a:noFill/>
-          </a:ln>
-          <a:effectLst/>
-        </p:spPr>
-        <p:style>
-          <a:lnRef idx="1">
-            <a:schemeClr val="accent1"/>
-          </a:lnRef>
-          <a:fillRef idx="3">
-            <a:schemeClr val="accent1"/>
-          </a:fillRef>
-          <a:effectRef idx="2">
-            <a:schemeClr val="accent1"/>
-          </a:effectRef>
-          <a:fontRef idx="minor">
-            <a:schemeClr val="lt1"/>
-          </a:fontRef>
-        </p:style>
-        <p:txBody>
-          <a:bodyPr rtlCol="0" anchor="ctr"/>
-          <a:lstStyle/>
-          <a:p>
-            <a:pPr algn="ctr"/>
-          </a:p>
-        </p:txBody>
-      </p:sp>
-      <p:sp>
-        <p:nvSpPr>
-          <p:cNvPr id="7" name="Rectangle 6"/>
-          <p:cNvSpPr/>
-          <p:nvPr/>
-        </p:nvSpPr>
-        <p:spPr>
-          <a:xfrm>
-            <a:off x="548640" y="4090659"/>
-            <a:ext cx="64008" cy="418612"/>
-          </a:xfrm>
-          <a:prstGeom prst="rect">
-            <a:avLst/>
-          </a:prstGeom>
-          <a:solidFill>
-            <a:srgbClr val="E1542A"/>
-          </a:solidFill>
-          <a:ln>
-            <a:noFill/>
-          </a:ln>
-          <a:effectLst/>
-        </p:spPr>
-        <p:style>
-          <a:lnRef idx="1">
-            <a:schemeClr val="accent1"/>
-          </a:lnRef>
-          <a:fillRef idx="3">
-            <a:schemeClr val="accent1"/>
-          </a:fillRef>
-          <a:effectRef idx="2">
-            <a:schemeClr val="accent1"/>
-          </a:effectRef>
-          <a:fontRef idx="minor">
-            <a:schemeClr val="lt1"/>
-          </a:fontRef>
-        </p:style>
-        <p:txBody>
-          <a:bodyPr rtlCol="0" anchor="ctr"/>
-          <a:lstStyle/>
-          <a:p>
-            <a:pPr algn="ctr"/>
-          </a:p>
-        </p:txBody>
-      </p:sp>
-      <p:sp>
-        <p:nvSpPr>
-          <p:cNvPr id="8" name="TextBox 7"/>
+          <p:cNvPr id="7" name="TextBox 6"/>
           <p:cNvSpPr txBox="1"/>
           <p:nvPr/>
         </p:nvSpPr>
@@ -17777,7 +17469,7 @@
       </p:sp>
       <p:sp>
         <p:nvSpPr>
-          <p:cNvPr id="9" name="Rounded Rectangle 8"/>
+          <p:cNvPr id="8" name="Rounded Rectangle 7"/>
           <p:cNvSpPr/>
           <p:nvPr/>
         </p:nvSpPr>
@@ -17823,7 +17515,7 @@
       </p:sp>
       <p:pic>
         <p:nvPicPr>
-          <p:cNvPr id="10" name="Picture 9" descr="message-square_168581.png"/>
+          <p:cNvPr id="9" name="Picture 8" descr="message-square_168581.png"/>
           <p:cNvPicPr>
             <a:picLocks noChangeAspect="1"/>
           </p:cNvPicPr>
@@ -17847,7 +17539,7 @@
       </p:pic>
       <p:sp>
         <p:nvSpPr>
-          <p:cNvPr id="11" name="TextBox 10"/>
+          <p:cNvPr id="10" name="TextBox 9"/>
           <p:cNvSpPr txBox="1"/>
           <p:nvPr/>
         </p:nvSpPr>
@@ -17893,7 +17585,7 @@
       </p:sp>
       <p:sp>
         <p:nvSpPr>
-          <p:cNvPr id="12" name="TextBox 11"/>
+          <p:cNvPr id="11" name="TextBox 10"/>
           <p:cNvSpPr txBox="1"/>
           <p:nvPr/>
         </p:nvSpPr>
@@ -17939,7 +17631,7 @@
       </p:sp>
       <p:sp>
         <p:nvSpPr>
-          <p:cNvPr id="13" name="Rounded Rectangle 12"/>
+          <p:cNvPr id="12" name="Rounded Rectangle 11"/>
           <p:cNvSpPr/>
           <p:nvPr/>
         </p:nvSpPr>
@@ -17985,7 +17677,7 @@
       </p:sp>
       <p:pic>
         <p:nvPicPr>
-          <p:cNvPr id="14" name="Picture 13" descr="terminal_168581.png"/>
+          <p:cNvPr id="13" name="Picture 12" descr="terminal_168581.png"/>
           <p:cNvPicPr>
             <a:picLocks noChangeAspect="1"/>
           </p:cNvPicPr>
@@ -18009,7 +17701,7 @@
       </p:pic>
       <p:sp>
         <p:nvSpPr>
-          <p:cNvPr id="15" name="TextBox 14"/>
+          <p:cNvPr id="14" name="TextBox 13"/>
           <p:cNvSpPr txBox="1"/>
           <p:nvPr/>
         </p:nvSpPr>
@@ -18055,7 +17747,7 @@
       </p:sp>
       <p:sp>
         <p:nvSpPr>
-          <p:cNvPr id="16" name="TextBox 15"/>
+          <p:cNvPr id="15" name="TextBox 14"/>
           <p:cNvSpPr txBox="1"/>
           <p:nvPr/>
         </p:nvSpPr>
@@ -18101,7 +17793,7 @@
       </p:sp>
       <p:sp>
         <p:nvSpPr>
-          <p:cNvPr id="17" name="Rounded Rectangle 16"/>
+          <p:cNvPr id="16" name="Rounded Rectangle 15"/>
           <p:cNvSpPr/>
           <p:nvPr/>
         </p:nvSpPr>
@@ -18147,7 +17839,7 @@
       </p:sp>
       <p:pic>
         <p:nvPicPr>
-          <p:cNvPr id="18" name="Picture 17" descr="palette_168581.png"/>
+          <p:cNvPr id="17" name="Picture 16" descr="palette_168581.png"/>
           <p:cNvPicPr>
             <a:picLocks noChangeAspect="1"/>
           </p:cNvPicPr>
@@ -18171,7 +17863,7 @@
       </p:pic>
       <p:sp>
         <p:nvSpPr>
-          <p:cNvPr id="19" name="TextBox 18"/>
+          <p:cNvPr id="18" name="TextBox 17"/>
           <p:cNvSpPr txBox="1"/>
           <p:nvPr/>
         </p:nvSpPr>
@@ -18217,7 +17909,7 @@
       </p:sp>
       <p:sp>
         <p:nvSpPr>
-          <p:cNvPr id="20" name="TextBox 19"/>
+          <p:cNvPr id="19" name="TextBox 18"/>
           <p:cNvSpPr txBox="1"/>
           <p:nvPr/>
         </p:nvSpPr>
@@ -18263,7 +17955,7 @@
       </p:sp>
       <p:sp>
         <p:nvSpPr>
-          <p:cNvPr id="21" name="Rounded Rectangle 20"/>
+          <p:cNvPr id="20" name="Rounded Rectangle 19"/>
           <p:cNvSpPr/>
           <p:nvPr/>
         </p:nvSpPr>
@@ -18309,7 +18001,7 @@
       </p:sp>
       <p:pic>
         <p:nvPicPr>
-          <p:cNvPr id="22" name="Picture 21" descr="workflow_168581.png"/>
+          <p:cNvPr id="21" name="Picture 20" descr="workflow_168581.png"/>
           <p:cNvPicPr>
             <a:picLocks noChangeAspect="1"/>
           </p:cNvPicPr>
@@ -18333,7 +18025,7 @@
       </p:pic>
       <p:sp>
         <p:nvSpPr>
-          <p:cNvPr id="23" name="TextBox 22"/>
+          <p:cNvPr id="22" name="TextBox 21"/>
           <p:cNvSpPr txBox="1"/>
           <p:nvPr/>
         </p:nvSpPr>
@@ -18379,7 +18071,7 @@
       </p:sp>
       <p:sp>
         <p:nvSpPr>
-          <p:cNvPr id="24" name="TextBox 23"/>
+          <p:cNvPr id="23" name="TextBox 22"/>
           <p:cNvSpPr txBox="1"/>
           <p:nvPr/>
         </p:nvSpPr>
@@ -18425,7 +18117,7 @@
       </p:sp>
       <p:sp>
         <p:nvSpPr>
-          <p:cNvPr id="25" name="Rounded Rectangle 24"/>
+          <p:cNvPr id="24" name="Rounded Rectangle 23"/>
           <p:cNvSpPr/>
           <p:nvPr/>
         </p:nvSpPr>
@@ -18471,7 +18163,7 @@
       </p:sp>
       <p:pic>
         <p:nvPicPr>
-          <p:cNvPr id="26" name="Picture 25" descr="database_168581.png"/>
+          <p:cNvPr id="25" name="Picture 24" descr="database_168581.png"/>
           <p:cNvPicPr>
             <a:picLocks noChangeAspect="1"/>
           </p:cNvPicPr>
@@ -18495,7 +18187,7 @@
       </p:pic>
       <p:sp>
         <p:nvSpPr>
-          <p:cNvPr id="27" name="TextBox 26"/>
+          <p:cNvPr id="26" name="TextBox 25"/>
           <p:cNvSpPr txBox="1"/>
           <p:nvPr/>
         </p:nvSpPr>
@@ -18541,7 +18233,7 @@
       </p:sp>
       <p:sp>
         <p:nvSpPr>
-          <p:cNvPr id="28" name="TextBox 27"/>
+          <p:cNvPr id="27" name="TextBox 26"/>
           <p:cNvSpPr txBox="1"/>
           <p:nvPr/>
         </p:nvSpPr>
@@ -18587,7 +18279,7 @@
       </p:sp>
       <p:sp>
         <p:nvSpPr>
-          <p:cNvPr id="29" name="Rounded Rectangle 28"/>
+          <p:cNvPr id="28" name="Rounded Rectangle 27"/>
           <p:cNvSpPr/>
           <p:nvPr/>
         </p:nvSpPr>
@@ -18633,7 +18325,7 @@
       </p:sp>
       <p:pic>
         <p:nvPicPr>
-          <p:cNvPr id="30" name="Picture 29" descr="credit-card_168581.png"/>
+          <p:cNvPr id="29" name="Picture 28" descr="credit-card_168581.png"/>
           <p:cNvPicPr>
             <a:picLocks noChangeAspect="1"/>
           </p:cNvPicPr>
@@ -18657,7 +18349,7 @@
       </p:pic>
       <p:sp>
         <p:nvSpPr>
-          <p:cNvPr id="31" name="TextBox 30"/>
+          <p:cNvPr id="30" name="TextBox 29"/>
           <p:cNvSpPr txBox="1"/>
           <p:nvPr/>
         </p:nvSpPr>
@@ -18703,7 +18395,7 @@
       </p:sp>
       <p:sp>
         <p:nvSpPr>
-          <p:cNvPr id="32" name="TextBox 31"/>
+          <p:cNvPr id="31" name="TextBox 30"/>
           <p:cNvSpPr txBox="1"/>
           <p:nvPr/>
         </p:nvSpPr>
@@ -18749,7 +18441,7 @@
       </p:sp>
       <p:cxnSp>
         <p:nvCxnSpPr>
-          <p:cNvPr id="33" name="Connector 32"/>
+          <p:cNvPr id="32" name="Connector 31"/>
           <p:cNvCxnSpPr/>
           <p:nvPr/>
         </p:nvCxnSpPr>
@@ -18757,6 +18449,42 @@
           <a:xfrm flipV="1">
             <a:off x="8284464" y="4736592"/>
             <a:ext cx="0" cy="137160"/>
+          </a:xfrm>
+          <a:prstGeom prst="line">
+            <a:avLst/>
+          </a:prstGeom>
+          <a:ln w="9525">
+            <a:solidFill>
+              <a:srgbClr val="D9D3C6"/>
+            </a:solidFill>
+          </a:ln>
+          <a:effectLst/>
+        </p:spPr>
+        <p:style>
+          <a:lnRef idx="2">
+            <a:schemeClr val="accent1"/>
+          </a:lnRef>
+          <a:fillRef idx="0">
+            <a:schemeClr val="accent1"/>
+          </a:fillRef>
+          <a:effectRef idx="1">
+            <a:schemeClr val="accent1"/>
+          </a:effectRef>
+          <a:fontRef idx="minor">
+            <a:schemeClr val="tx1"/>
+          </a:fontRef>
+        </p:style>
+      </p:cxnSp>
+      <p:cxnSp>
+        <p:nvCxnSpPr>
+          <p:cNvPr id="33" name="Connector 32"/>
+          <p:cNvCxnSpPr/>
+          <p:nvPr/>
+        </p:nvCxnSpPr>
+        <p:spPr>
+          <a:xfrm flipV="1">
+            <a:off x="8284464" y="4805172"/>
+            <a:ext cx="118784" cy="68580"/>
           </a:xfrm>
           <a:prstGeom prst="line">
             <a:avLst/>
@@ -18790,8 +18518,8 @@
           <p:nvPr/>
         </p:nvCxnSpPr>
         <p:spPr>
-          <a:xfrm flipV="1">
-            <a:off x="8284464" y="4805172"/>
+          <a:xfrm>
+            <a:off x="8284464" y="4873752"/>
             <a:ext cx="118784" cy="68580"/>
           </a:xfrm>
           <a:prstGeom prst="line">
@@ -18828,7 +18556,7 @@
         <p:spPr>
           <a:xfrm>
             <a:off x="8284464" y="4873752"/>
-            <a:ext cx="118784" cy="68580"/>
+            <a:ext cx="0" cy="137160"/>
           </a:xfrm>
           <a:prstGeom prst="line">
             <a:avLst/>
@@ -18862,9 +18590,9 @@
           <p:nvPr/>
         </p:nvCxnSpPr>
         <p:spPr>
-          <a:xfrm>
-            <a:off x="8284464" y="4873752"/>
-            <a:ext cx="0" cy="137160"/>
+          <a:xfrm flipH="1">
+            <a:off x="8165679" y="4873752"/>
+            <a:ext cx="118785" cy="68580"/>
           </a:xfrm>
           <a:prstGeom prst="line">
             <a:avLst/>
@@ -18898,8 +18626,8 @@
           <p:nvPr/>
         </p:nvCxnSpPr>
         <p:spPr>
-          <a:xfrm flipH="1">
-            <a:off x="8165679" y="4873752"/>
+          <a:xfrm flipH="1" flipV="1">
+            <a:off x="8165679" y="4805172"/>
             <a:ext cx="118785" cy="68580"/>
           </a:xfrm>
           <a:prstGeom prst="line">
@@ -18927,45 +18655,9 @@
           </a:fontRef>
         </p:style>
       </p:cxnSp>
-      <p:cxnSp>
-        <p:nvCxnSpPr>
-          <p:cNvPr id="38" name="Connector 37"/>
-          <p:cNvCxnSpPr/>
-          <p:nvPr/>
-        </p:nvCxnSpPr>
-        <p:spPr>
-          <a:xfrm flipH="1" flipV="1">
-            <a:off x="8165679" y="4805172"/>
-            <a:ext cx="118785" cy="68580"/>
-          </a:xfrm>
-          <a:prstGeom prst="line">
-            <a:avLst/>
-          </a:prstGeom>
-          <a:ln w="9525">
-            <a:solidFill>
-              <a:srgbClr val="D9D3C6"/>
-            </a:solidFill>
-          </a:ln>
-          <a:effectLst/>
-        </p:spPr>
-        <p:style>
-          <a:lnRef idx="2">
-            <a:schemeClr val="accent1"/>
-          </a:lnRef>
-          <a:fillRef idx="0">
-            <a:schemeClr val="accent1"/>
-          </a:fillRef>
-          <a:effectRef idx="1">
-            <a:schemeClr val="accent1"/>
-          </a:effectRef>
-          <a:fontRef idx="minor">
-            <a:schemeClr val="tx1"/>
-          </a:fontRef>
-        </p:style>
-      </p:cxnSp>
-      <p:sp>
-        <p:nvSpPr>
-          <p:cNvPr id="39" name="Rounded Rectangle 38"/>
+      <p:sp>
+        <p:nvSpPr>
+          <p:cNvPr id="38" name="Rounded Rectangle 37"/>
           <p:cNvSpPr/>
           <p:nvPr/>
         </p:nvSpPr>
@@ -19011,7 +18703,7 @@
       </p:sp>
       <p:sp>
         <p:nvSpPr>
-          <p:cNvPr id="40" name="Rounded Rectangle 39"/>
+          <p:cNvPr id="39" name="Rounded Rectangle 38"/>
           <p:cNvSpPr/>
           <p:nvPr/>
         </p:nvSpPr>
@@ -19057,7 +18749,7 @@
       </p:sp>
       <p:sp>
         <p:nvSpPr>
-          <p:cNvPr id="41" name="Rounded Rectangle 40"/>
+          <p:cNvPr id="40" name="Rounded Rectangle 39"/>
           <p:cNvSpPr/>
           <p:nvPr/>
         </p:nvSpPr>
@@ -19103,7 +18795,7 @@
       </p:sp>
       <p:sp>
         <p:nvSpPr>
-          <p:cNvPr id="42" name="Rounded Rectangle 41"/>
+          <p:cNvPr id="41" name="Rounded Rectangle 40"/>
           <p:cNvSpPr/>
           <p:nvPr/>
         </p:nvSpPr>
@@ -19149,7 +18841,7 @@
       </p:sp>
       <p:sp>
         <p:nvSpPr>
-          <p:cNvPr id="43" name="Rounded Rectangle 42"/>
+          <p:cNvPr id="42" name="Rounded Rectangle 41"/>
           <p:cNvSpPr/>
           <p:nvPr/>
         </p:nvSpPr>
@@ -19195,7 +18887,7 @@
       </p:sp>
       <p:sp>
         <p:nvSpPr>
-          <p:cNvPr id="44" name="Rounded Rectangle 43"/>
+          <p:cNvPr id="43" name="Rounded Rectangle 42"/>
           <p:cNvSpPr/>
           <p:nvPr/>
         </p:nvSpPr>
@@ -19241,7 +18933,7 @@
       </p:sp>
       <p:sp>
         <p:nvSpPr>
-          <p:cNvPr id="45" name="Rounded Rectangle 44"/>
+          <p:cNvPr id="44" name="Rounded Rectangle 43"/>
           <p:cNvSpPr/>
           <p:nvPr/>
         </p:nvSpPr>
@@ -19287,7 +18979,7 @@
       </p:sp>
       <p:sp>
         <p:nvSpPr>
-          <p:cNvPr id="46" name="TextBox 45"/>
+          <p:cNvPr id="45" name="TextBox 44"/>
           <p:cNvSpPr txBox="1"/>
           <p:nvPr/>
         </p:nvSpPr>
@@ -19333,7 +19025,7 @@
       </p:sp>
       <p:sp>
         <p:nvSpPr>
-          <p:cNvPr id="47" name="TextBox 46"/>
+          <p:cNvPr id="46" name="TextBox 45"/>
           <p:cNvSpPr txBox="1"/>
           <p:nvPr/>
         </p:nvSpPr>
@@ -19533,14 +19225,60 @@
       </p:sp>
       <p:sp>
         <p:nvSpPr>
-          <p:cNvPr id="5" name="Rectangle 4"/>
+          <p:cNvPr id="5" name="Rounded Rectangle 4"/>
           <p:cNvSpPr/>
           <p:nvPr/>
         </p:nvSpPr>
         <p:spPr>
           <a:xfrm>
-            <a:off x="566928" y="1191006"/>
-            <a:ext cx="1097280" cy="45720"/>
+            <a:off x="548640" y="4050791"/>
+            <a:ext cx="8046720" cy="498347"/>
+          </a:xfrm>
+          <a:prstGeom prst="roundRect">
+            <a:avLst>
+              <a:gd name="adj" fmla="val 8000"/>
+            </a:avLst>
+          </a:prstGeom>
+          <a:solidFill>
+            <a:srgbClr val="EAF3FA"/>
+          </a:solidFill>
+          <a:ln>
+            <a:noFill/>
+          </a:ln>
+          <a:effectLst/>
+        </p:spPr>
+        <p:style>
+          <a:lnRef idx="1">
+            <a:schemeClr val="accent1"/>
+          </a:lnRef>
+          <a:fillRef idx="3">
+            <a:schemeClr val="accent1"/>
+          </a:fillRef>
+          <a:effectRef idx="2">
+            <a:schemeClr val="accent1"/>
+          </a:effectRef>
+          <a:fontRef idx="minor">
+            <a:schemeClr val="lt1"/>
+          </a:fontRef>
+        </p:style>
+        <p:txBody>
+          <a:bodyPr rtlCol="0" anchor="ctr"/>
+          <a:lstStyle/>
+          <a:p>
+            <a:pPr algn="ctr"/>
+          </a:p>
+        </p:txBody>
+      </p:sp>
+      <p:sp>
+        <p:nvSpPr>
+          <p:cNvPr id="6" name="Rectangle 5"/>
+          <p:cNvSpPr/>
+          <p:nvPr/>
+        </p:nvSpPr>
+        <p:spPr>
+          <a:xfrm>
+            <a:off x="548640" y="4090659"/>
+            <a:ext cx="64008" cy="418612"/>
           </a:xfrm>
           <a:prstGeom prst="rect">
             <a:avLst/>
@@ -19577,97 +19315,7 @@
       </p:sp>
       <p:sp>
         <p:nvSpPr>
-          <p:cNvPr id="6" name="Rounded Rectangle 5"/>
-          <p:cNvSpPr/>
-          <p:nvPr/>
-        </p:nvSpPr>
-        <p:spPr>
-          <a:xfrm>
-            <a:off x="548640" y="4050791"/>
-            <a:ext cx="8046720" cy="498347"/>
-          </a:xfrm>
-          <a:prstGeom prst="roundRect">
-            <a:avLst>
-              <a:gd name="adj" fmla="val 8000"/>
-            </a:avLst>
-          </a:prstGeom>
-          <a:solidFill>
-            <a:srgbClr val="EAF3FA"/>
-          </a:solidFill>
-          <a:ln>
-            <a:noFill/>
-          </a:ln>
-          <a:effectLst/>
-        </p:spPr>
-        <p:style>
-          <a:lnRef idx="1">
-            <a:schemeClr val="accent1"/>
-          </a:lnRef>
-          <a:fillRef idx="3">
-            <a:schemeClr val="accent1"/>
-          </a:fillRef>
-          <a:effectRef idx="2">
-            <a:schemeClr val="accent1"/>
-          </a:effectRef>
-          <a:fontRef idx="minor">
-            <a:schemeClr val="lt1"/>
-          </a:fontRef>
-        </p:style>
-        <p:txBody>
-          <a:bodyPr rtlCol="0" anchor="ctr"/>
-          <a:lstStyle/>
-          <a:p>
-            <a:pPr algn="ctr"/>
-          </a:p>
-        </p:txBody>
-      </p:sp>
-      <p:sp>
-        <p:nvSpPr>
-          <p:cNvPr id="7" name="Rectangle 6"/>
-          <p:cNvSpPr/>
-          <p:nvPr/>
-        </p:nvSpPr>
-        <p:spPr>
-          <a:xfrm>
-            <a:off x="548640" y="4090659"/>
-            <a:ext cx="64008" cy="418612"/>
-          </a:xfrm>
-          <a:prstGeom prst="rect">
-            <a:avLst/>
-          </a:prstGeom>
-          <a:solidFill>
-            <a:srgbClr val="E1542A"/>
-          </a:solidFill>
-          <a:ln>
-            <a:noFill/>
-          </a:ln>
-          <a:effectLst/>
-        </p:spPr>
-        <p:style>
-          <a:lnRef idx="1">
-            <a:schemeClr val="accent1"/>
-          </a:lnRef>
-          <a:fillRef idx="3">
-            <a:schemeClr val="accent1"/>
-          </a:fillRef>
-          <a:effectRef idx="2">
-            <a:schemeClr val="accent1"/>
-          </a:effectRef>
-          <a:fontRef idx="minor">
-            <a:schemeClr val="lt1"/>
-          </a:fontRef>
-        </p:style>
-        <p:txBody>
-          <a:bodyPr rtlCol="0" anchor="ctr"/>
-          <a:lstStyle/>
-          <a:p>
-            <a:pPr algn="ctr"/>
-          </a:p>
-        </p:txBody>
-      </p:sp>
-      <p:sp>
-        <p:nvSpPr>
-          <p:cNvPr id="8" name="TextBox 7"/>
+          <p:cNvPr id="7" name="TextBox 6"/>
           <p:cNvSpPr txBox="1"/>
           <p:nvPr/>
         </p:nvSpPr>
@@ -19722,7 +19370,7 @@
       </p:sp>
       <p:sp>
         <p:nvSpPr>
-          <p:cNvPr id="9" name="Rounded Rectangle 8"/>
+          <p:cNvPr id="8" name="Rounded Rectangle 7"/>
           <p:cNvSpPr/>
           <p:nvPr/>
         </p:nvSpPr>
@@ -19770,7 +19418,7 @@
       </p:sp>
       <p:sp>
         <p:nvSpPr>
-          <p:cNvPr id="10" name="Rounded Rectangle 9"/>
+          <p:cNvPr id="9" name="Rounded Rectangle 8"/>
           <p:cNvSpPr/>
           <p:nvPr/>
         </p:nvSpPr>
@@ -19816,7 +19464,7 @@
       </p:sp>
       <p:pic>
         <p:nvPicPr>
-          <p:cNvPr id="11" name="Picture 10" descr="arrow-down_168581.png"/>
+          <p:cNvPr id="10" name="Picture 9" descr="arrow-down_168581.png"/>
           <p:cNvPicPr>
             <a:picLocks noChangeAspect="1"/>
           </p:cNvPicPr>
@@ -19840,7 +19488,7 @@
       </p:pic>
       <p:sp>
         <p:nvSpPr>
-          <p:cNvPr id="12" name="TextBox 11"/>
+          <p:cNvPr id="11" name="TextBox 10"/>
           <p:cNvSpPr txBox="1"/>
           <p:nvPr/>
         </p:nvSpPr>
@@ -19886,7 +19534,7 @@
       </p:sp>
       <p:sp>
         <p:nvSpPr>
-          <p:cNvPr id="13" name="TextBox 12"/>
+          <p:cNvPr id="12" name="TextBox 11"/>
           <p:cNvSpPr txBox="1"/>
           <p:nvPr/>
         </p:nvSpPr>
@@ -19932,7 +19580,7 @@
       </p:sp>
       <p:sp>
         <p:nvSpPr>
-          <p:cNvPr id="14" name="Rounded Rectangle 13"/>
+          <p:cNvPr id="13" name="Rounded Rectangle 12"/>
           <p:cNvSpPr/>
           <p:nvPr/>
         </p:nvSpPr>
@@ -19978,7 +19626,7 @@
       </p:sp>
       <p:sp>
         <p:nvSpPr>
-          <p:cNvPr id="15" name="TextBox 14"/>
+          <p:cNvPr id="14" name="TextBox 13"/>
           <p:cNvSpPr txBox="1"/>
           <p:nvPr/>
         </p:nvSpPr>
@@ -20024,7 +19672,7 @@
       </p:sp>
       <p:sp>
         <p:nvSpPr>
-          <p:cNvPr id="16" name="Rounded Rectangle 15"/>
+          <p:cNvPr id="15" name="Rounded Rectangle 14"/>
           <p:cNvSpPr/>
           <p:nvPr/>
         </p:nvSpPr>
@@ -20070,7 +19718,7 @@
       </p:sp>
       <p:sp>
         <p:nvSpPr>
-          <p:cNvPr id="17" name="TextBox 16"/>
+          <p:cNvPr id="16" name="TextBox 15"/>
           <p:cNvSpPr txBox="1"/>
           <p:nvPr/>
         </p:nvSpPr>
@@ -20116,7 +19764,7 @@
       </p:sp>
       <p:sp>
         <p:nvSpPr>
-          <p:cNvPr id="18" name="Rounded Rectangle 17"/>
+          <p:cNvPr id="17" name="Rounded Rectangle 16"/>
           <p:cNvSpPr/>
           <p:nvPr/>
         </p:nvSpPr>
@@ -20162,7 +19810,7 @@
       </p:sp>
       <p:sp>
         <p:nvSpPr>
-          <p:cNvPr id="19" name="TextBox 18"/>
+          <p:cNvPr id="18" name="TextBox 17"/>
           <p:cNvSpPr txBox="1"/>
           <p:nvPr/>
         </p:nvSpPr>
@@ -20208,7 +19856,7 @@
       </p:sp>
       <p:sp>
         <p:nvSpPr>
-          <p:cNvPr id="20" name="Rounded Rectangle 19"/>
+          <p:cNvPr id="19" name="Rounded Rectangle 18"/>
           <p:cNvSpPr/>
           <p:nvPr/>
         </p:nvSpPr>
@@ -20254,7 +19902,7 @@
       </p:sp>
       <p:sp>
         <p:nvSpPr>
-          <p:cNvPr id="21" name="TextBox 20"/>
+          <p:cNvPr id="20" name="TextBox 19"/>
           <p:cNvSpPr txBox="1"/>
           <p:nvPr/>
         </p:nvSpPr>
@@ -20300,7 +19948,7 @@
       </p:sp>
       <p:sp>
         <p:nvSpPr>
-          <p:cNvPr id="22" name="Rounded Rectangle 21"/>
+          <p:cNvPr id="21" name="Rounded Rectangle 20"/>
           <p:cNvSpPr/>
           <p:nvPr/>
         </p:nvSpPr>
@@ -20348,7 +19996,7 @@
       </p:sp>
       <p:sp>
         <p:nvSpPr>
-          <p:cNvPr id="23" name="Rounded Rectangle 22"/>
+          <p:cNvPr id="22" name="Rounded Rectangle 21"/>
           <p:cNvSpPr/>
           <p:nvPr/>
         </p:nvSpPr>
@@ -20394,7 +20042,7 @@
       </p:sp>
       <p:pic>
         <p:nvPicPr>
-          <p:cNvPr id="24" name="Picture 23" descr="arrow-up_e1542a.png"/>
+          <p:cNvPr id="23" name="Picture 22" descr="arrow-up_e1542a.png"/>
           <p:cNvPicPr>
             <a:picLocks noChangeAspect="1"/>
           </p:cNvPicPr>
@@ -20418,7 +20066,7 @@
       </p:pic>
       <p:sp>
         <p:nvSpPr>
-          <p:cNvPr id="25" name="TextBox 24"/>
+          <p:cNvPr id="24" name="TextBox 23"/>
           <p:cNvSpPr txBox="1"/>
           <p:nvPr/>
         </p:nvSpPr>
@@ -20464,7 +20112,7 @@
       </p:sp>
       <p:sp>
         <p:nvSpPr>
-          <p:cNvPr id="26" name="TextBox 25"/>
+          <p:cNvPr id="25" name="TextBox 24"/>
           <p:cNvSpPr txBox="1"/>
           <p:nvPr/>
         </p:nvSpPr>
@@ -20510,7 +20158,7 @@
       </p:sp>
       <p:sp>
         <p:nvSpPr>
-          <p:cNvPr id="27" name="TextBox 26"/>
+          <p:cNvPr id="26" name="TextBox 25"/>
           <p:cNvSpPr txBox="1"/>
           <p:nvPr/>
         </p:nvSpPr>
@@ -20556,7 +20204,7 @@
       </p:sp>
       <p:sp>
         <p:nvSpPr>
-          <p:cNvPr id="28" name="TextBox 27"/>
+          <p:cNvPr id="27" name="TextBox 26"/>
           <p:cNvSpPr txBox="1"/>
           <p:nvPr/>
         </p:nvSpPr>
@@ -20602,7 +20250,7 @@
       </p:sp>
       <p:cxnSp>
         <p:nvCxnSpPr>
-          <p:cNvPr id="29" name="Connector 28"/>
+          <p:cNvPr id="28" name="Connector 27"/>
           <p:cNvCxnSpPr/>
           <p:nvPr/>
         </p:nvCxnSpPr>
@@ -20610,6 +20258,42 @@
           <a:xfrm flipV="1">
             <a:off x="8284464" y="4736592"/>
             <a:ext cx="0" cy="137160"/>
+          </a:xfrm>
+          <a:prstGeom prst="line">
+            <a:avLst/>
+          </a:prstGeom>
+          <a:ln w="9525">
+            <a:solidFill>
+              <a:srgbClr val="D9D3C6"/>
+            </a:solidFill>
+          </a:ln>
+          <a:effectLst/>
+        </p:spPr>
+        <p:style>
+          <a:lnRef idx="2">
+            <a:schemeClr val="accent1"/>
+          </a:lnRef>
+          <a:fillRef idx="0">
+            <a:schemeClr val="accent1"/>
+          </a:fillRef>
+          <a:effectRef idx="1">
+            <a:schemeClr val="accent1"/>
+          </a:effectRef>
+          <a:fontRef idx="minor">
+            <a:schemeClr val="tx1"/>
+          </a:fontRef>
+        </p:style>
+      </p:cxnSp>
+      <p:cxnSp>
+        <p:nvCxnSpPr>
+          <p:cNvPr id="29" name="Connector 28"/>
+          <p:cNvCxnSpPr/>
+          <p:nvPr/>
+        </p:nvCxnSpPr>
+        <p:spPr>
+          <a:xfrm flipV="1">
+            <a:off x="8284464" y="4805172"/>
+            <a:ext cx="118784" cy="68580"/>
           </a:xfrm>
           <a:prstGeom prst="line">
             <a:avLst/>
@@ -20643,8 +20327,8 @@
           <p:nvPr/>
         </p:nvCxnSpPr>
         <p:spPr>
-          <a:xfrm flipV="1">
-            <a:off x="8284464" y="4805172"/>
+          <a:xfrm>
+            <a:off x="8284464" y="4873752"/>
             <a:ext cx="118784" cy="68580"/>
           </a:xfrm>
           <a:prstGeom prst="line">
@@ -20681,7 +20365,7 @@
         <p:spPr>
           <a:xfrm>
             <a:off x="8284464" y="4873752"/>
-            <a:ext cx="118784" cy="68580"/>
+            <a:ext cx="0" cy="137160"/>
           </a:xfrm>
           <a:prstGeom prst="line">
             <a:avLst/>
@@ -20715,9 +20399,9 @@
           <p:nvPr/>
         </p:nvCxnSpPr>
         <p:spPr>
-          <a:xfrm>
-            <a:off x="8284464" y="4873752"/>
-            <a:ext cx="0" cy="137160"/>
+          <a:xfrm flipH="1">
+            <a:off x="8165679" y="4873752"/>
+            <a:ext cx="118785" cy="68580"/>
           </a:xfrm>
           <a:prstGeom prst="line">
             <a:avLst/>
@@ -20751,8 +20435,8 @@
           <p:nvPr/>
         </p:nvCxnSpPr>
         <p:spPr>
-          <a:xfrm flipH="1">
-            <a:off x="8165679" y="4873752"/>
+          <a:xfrm flipH="1" flipV="1">
+            <a:off x="8165679" y="4805172"/>
             <a:ext cx="118785" cy="68580"/>
           </a:xfrm>
           <a:prstGeom prst="line">
@@ -20780,45 +20464,9 @@
           </a:fontRef>
         </p:style>
       </p:cxnSp>
-      <p:cxnSp>
-        <p:nvCxnSpPr>
-          <p:cNvPr id="34" name="Connector 33"/>
-          <p:cNvCxnSpPr/>
-          <p:nvPr/>
-        </p:nvCxnSpPr>
-        <p:spPr>
-          <a:xfrm flipH="1" flipV="1">
-            <a:off x="8165679" y="4805172"/>
-            <a:ext cx="118785" cy="68580"/>
-          </a:xfrm>
-          <a:prstGeom prst="line">
-            <a:avLst/>
-          </a:prstGeom>
-          <a:ln w="9525">
-            <a:solidFill>
-              <a:srgbClr val="D9D3C6"/>
-            </a:solidFill>
-          </a:ln>
-          <a:effectLst/>
-        </p:spPr>
-        <p:style>
-          <a:lnRef idx="2">
-            <a:schemeClr val="accent1"/>
-          </a:lnRef>
-          <a:fillRef idx="0">
-            <a:schemeClr val="accent1"/>
-          </a:fillRef>
-          <a:effectRef idx="1">
-            <a:schemeClr val="accent1"/>
-          </a:effectRef>
-          <a:fontRef idx="minor">
-            <a:schemeClr val="tx1"/>
-          </a:fontRef>
-        </p:style>
-      </p:cxnSp>
-      <p:sp>
-        <p:nvSpPr>
-          <p:cNvPr id="35" name="Rounded Rectangle 34"/>
+      <p:sp>
+        <p:nvSpPr>
+          <p:cNvPr id="34" name="Rounded Rectangle 33"/>
           <p:cNvSpPr/>
           <p:nvPr/>
         </p:nvSpPr>
@@ -20864,7 +20512,7 @@
       </p:sp>
       <p:sp>
         <p:nvSpPr>
-          <p:cNvPr id="36" name="Rounded Rectangle 35"/>
+          <p:cNvPr id="35" name="Rounded Rectangle 34"/>
           <p:cNvSpPr/>
           <p:nvPr/>
         </p:nvSpPr>
@@ -20910,7 +20558,7 @@
       </p:sp>
       <p:sp>
         <p:nvSpPr>
-          <p:cNvPr id="37" name="Rounded Rectangle 36"/>
+          <p:cNvPr id="36" name="Rounded Rectangle 35"/>
           <p:cNvSpPr/>
           <p:nvPr/>
         </p:nvSpPr>
@@ -20956,7 +20604,7 @@
       </p:sp>
       <p:sp>
         <p:nvSpPr>
-          <p:cNvPr id="38" name="Rounded Rectangle 37"/>
+          <p:cNvPr id="37" name="Rounded Rectangle 36"/>
           <p:cNvSpPr/>
           <p:nvPr/>
         </p:nvSpPr>
@@ -21002,7 +20650,7 @@
       </p:sp>
       <p:sp>
         <p:nvSpPr>
-          <p:cNvPr id="39" name="Rounded Rectangle 38"/>
+          <p:cNvPr id="38" name="Rounded Rectangle 37"/>
           <p:cNvSpPr/>
           <p:nvPr/>
         </p:nvSpPr>
@@ -21048,7 +20696,7 @@
       </p:sp>
       <p:sp>
         <p:nvSpPr>
-          <p:cNvPr id="40" name="Rounded Rectangle 39"/>
+          <p:cNvPr id="39" name="Rounded Rectangle 38"/>
           <p:cNvSpPr/>
           <p:nvPr/>
         </p:nvSpPr>
@@ -21094,7 +20742,7 @@
       </p:sp>
       <p:sp>
         <p:nvSpPr>
-          <p:cNvPr id="41" name="Rounded Rectangle 40"/>
+          <p:cNvPr id="40" name="Rounded Rectangle 39"/>
           <p:cNvSpPr/>
           <p:nvPr/>
         </p:nvSpPr>
@@ -21140,7 +20788,7 @@
       </p:sp>
       <p:sp>
         <p:nvSpPr>
-          <p:cNvPr id="42" name="TextBox 41"/>
+          <p:cNvPr id="41" name="TextBox 40"/>
           <p:cNvSpPr txBox="1"/>
           <p:nvPr/>
         </p:nvSpPr>
@@ -21186,7 +20834,7 @@
       </p:sp>
       <p:sp>
         <p:nvSpPr>
-          <p:cNvPr id="43" name="TextBox 42"/>
+          <p:cNvPr id="42" name="TextBox 41"/>
           <p:cNvSpPr txBox="1"/>
           <p:nvPr/>
         </p:nvSpPr>
@@ -21386,51 +21034,7 @@
       </p:sp>
       <p:sp>
         <p:nvSpPr>
-          <p:cNvPr id="5" name="Rectangle 4"/>
-          <p:cNvSpPr/>
-          <p:nvPr/>
-        </p:nvSpPr>
-        <p:spPr>
-          <a:xfrm>
-            <a:off x="566928" y="1191006"/>
-            <a:ext cx="1097280" cy="45720"/>
-          </a:xfrm>
-          <a:prstGeom prst="rect">
-            <a:avLst/>
-          </a:prstGeom>
-          <a:solidFill>
-            <a:srgbClr val="E1542A"/>
-          </a:solidFill>
-          <a:ln>
-            <a:noFill/>
-          </a:ln>
-          <a:effectLst/>
-        </p:spPr>
-        <p:style>
-          <a:lnRef idx="1">
-            <a:schemeClr val="accent1"/>
-          </a:lnRef>
-          <a:fillRef idx="3">
-            <a:schemeClr val="accent1"/>
-          </a:fillRef>
-          <a:effectRef idx="2">
-            <a:schemeClr val="accent1"/>
-          </a:effectRef>
-          <a:fontRef idx="minor">
-            <a:schemeClr val="lt1"/>
-          </a:fontRef>
-        </p:style>
-        <p:txBody>
-          <a:bodyPr rtlCol="0" anchor="ctr"/>
-          <a:lstStyle/>
-          <a:p>
-            <a:pPr algn="ctr"/>
-          </a:p>
-        </p:txBody>
-      </p:sp>
-      <p:sp>
-        <p:nvSpPr>
-          <p:cNvPr id="6" name="Rounded Rectangle 5"/>
+          <p:cNvPr id="5" name="Rounded Rectangle 4"/>
           <p:cNvSpPr/>
           <p:nvPr/>
         </p:nvSpPr>
@@ -21478,7 +21082,7 @@
       </p:sp>
       <p:sp>
         <p:nvSpPr>
-          <p:cNvPr id="7" name="Rounded Rectangle 6"/>
+          <p:cNvPr id="6" name="Rounded Rectangle 5"/>
           <p:cNvSpPr/>
           <p:nvPr/>
         </p:nvSpPr>
@@ -21524,7 +21128,7 @@
       </p:sp>
       <p:pic>
         <p:nvPicPr>
-          <p:cNvPr id="8" name="Picture 7" descr="heart-pulse_e1542a.png"/>
+          <p:cNvPr id="7" name="Picture 6" descr="heart-pulse_e1542a.png"/>
           <p:cNvPicPr>
             <a:picLocks noChangeAspect="1"/>
           </p:cNvPicPr>
@@ -21548,7 +21152,7 @@
       </p:pic>
       <p:sp>
         <p:nvSpPr>
-          <p:cNvPr id="9" name="TextBox 8"/>
+          <p:cNvPr id="8" name="TextBox 7"/>
           <p:cNvSpPr txBox="1"/>
           <p:nvPr/>
         </p:nvSpPr>
@@ -21594,7 +21198,7 @@
       </p:sp>
       <p:sp>
         <p:nvSpPr>
-          <p:cNvPr id="10" name="TextBox 9"/>
+          <p:cNvPr id="9" name="TextBox 8"/>
           <p:cNvSpPr txBox="1"/>
           <p:nvPr/>
         </p:nvSpPr>
@@ -21640,7 +21244,7 @@
       </p:sp>
       <p:sp>
         <p:nvSpPr>
-          <p:cNvPr id="11" name="Rounded Rectangle 10"/>
+          <p:cNvPr id="10" name="Rounded Rectangle 9"/>
           <p:cNvSpPr/>
           <p:nvPr/>
         </p:nvSpPr>
@@ -21688,7 +21292,7 @@
       </p:sp>
       <p:sp>
         <p:nvSpPr>
-          <p:cNvPr id="12" name="Rounded Rectangle 11"/>
+          <p:cNvPr id="11" name="Rounded Rectangle 10"/>
           <p:cNvSpPr/>
           <p:nvPr/>
         </p:nvSpPr>
@@ -21734,7 +21338,7 @@
       </p:sp>
       <p:pic>
         <p:nvPicPr>
-          <p:cNvPr id="13" name="Picture 12" descr="scan-eye_e1542a.png"/>
+          <p:cNvPr id="12" name="Picture 11" descr="scan-eye_e1542a.png"/>
           <p:cNvPicPr>
             <a:picLocks noChangeAspect="1"/>
           </p:cNvPicPr>
@@ -21758,7 +21362,7 @@
       </p:pic>
       <p:sp>
         <p:nvSpPr>
-          <p:cNvPr id="14" name="TextBox 13"/>
+          <p:cNvPr id="13" name="TextBox 12"/>
           <p:cNvSpPr txBox="1"/>
           <p:nvPr/>
         </p:nvSpPr>
@@ -21804,7 +21408,7 @@
       </p:sp>
       <p:sp>
         <p:nvSpPr>
-          <p:cNvPr id="15" name="TextBox 14"/>
+          <p:cNvPr id="14" name="TextBox 13"/>
           <p:cNvSpPr txBox="1"/>
           <p:nvPr/>
         </p:nvSpPr>
@@ -21850,7 +21454,7 @@
       </p:sp>
       <p:sp>
         <p:nvSpPr>
-          <p:cNvPr id="16" name="Rounded Rectangle 15"/>
+          <p:cNvPr id="15" name="Rounded Rectangle 14"/>
           <p:cNvSpPr/>
           <p:nvPr/>
         </p:nvSpPr>
@@ -21898,7 +21502,7 @@
       </p:sp>
       <p:sp>
         <p:nvSpPr>
-          <p:cNvPr id="17" name="Rounded Rectangle 16"/>
+          <p:cNvPr id="16" name="Rounded Rectangle 15"/>
           <p:cNvSpPr/>
           <p:nvPr/>
         </p:nvSpPr>
@@ -21944,7 +21548,7 @@
       </p:sp>
       <p:pic>
         <p:nvPicPr>
-          <p:cNvPr id="18" name="Picture 17" descr="gauge_e1542a.png"/>
+          <p:cNvPr id="17" name="Picture 16" descr="gauge_e1542a.png"/>
           <p:cNvPicPr>
             <a:picLocks noChangeAspect="1"/>
           </p:cNvPicPr>
@@ -21968,7 +21572,7 @@
       </p:pic>
       <p:sp>
         <p:nvSpPr>
-          <p:cNvPr id="19" name="TextBox 18"/>
+          <p:cNvPr id="18" name="TextBox 17"/>
           <p:cNvSpPr txBox="1"/>
           <p:nvPr/>
         </p:nvSpPr>
@@ -22014,7 +21618,7 @@
       </p:sp>
       <p:sp>
         <p:nvSpPr>
-          <p:cNvPr id="20" name="TextBox 19"/>
+          <p:cNvPr id="19" name="TextBox 18"/>
           <p:cNvSpPr txBox="1"/>
           <p:nvPr/>
         </p:nvSpPr>
@@ -22060,7 +21664,7 @@
       </p:sp>
       <p:sp>
         <p:nvSpPr>
-          <p:cNvPr id="21" name="Rounded Rectangle 20"/>
+          <p:cNvPr id="20" name="Rounded Rectangle 19"/>
           <p:cNvSpPr/>
           <p:nvPr/>
         </p:nvSpPr>
@@ -22108,7 +21712,7 @@
       </p:sp>
       <p:sp>
         <p:nvSpPr>
-          <p:cNvPr id="22" name="Rounded Rectangle 21"/>
+          <p:cNvPr id="21" name="Rounded Rectangle 20"/>
           <p:cNvSpPr/>
           <p:nvPr/>
         </p:nvSpPr>
@@ -22154,7 +21758,7 @@
       </p:sp>
       <p:pic>
         <p:nvPicPr>
-          <p:cNvPr id="23" name="Picture 22" descr="copy_e1542a.png"/>
+          <p:cNvPr id="22" name="Picture 21" descr="copy_e1542a.png"/>
           <p:cNvPicPr>
             <a:picLocks noChangeAspect="1"/>
           </p:cNvPicPr>
@@ -22178,7 +21782,7 @@
       </p:pic>
       <p:sp>
         <p:nvSpPr>
-          <p:cNvPr id="24" name="TextBox 23"/>
+          <p:cNvPr id="23" name="TextBox 22"/>
           <p:cNvSpPr txBox="1"/>
           <p:nvPr/>
         </p:nvSpPr>
@@ -22224,7 +21828,7 @@
       </p:sp>
       <p:sp>
         <p:nvSpPr>
-          <p:cNvPr id="25" name="TextBox 24"/>
+          <p:cNvPr id="24" name="TextBox 23"/>
           <p:cNvSpPr txBox="1"/>
           <p:nvPr/>
         </p:nvSpPr>
@@ -22270,7 +21874,7 @@
       </p:sp>
       <p:sp>
         <p:nvSpPr>
-          <p:cNvPr id="26" name="Rounded Rectangle 25"/>
+          <p:cNvPr id="25" name="Rounded Rectangle 24"/>
           <p:cNvSpPr/>
           <p:nvPr/>
         </p:nvSpPr>
@@ -22318,7 +21922,7 @@
       </p:sp>
       <p:sp>
         <p:nvSpPr>
-          <p:cNvPr id="27" name="Rounded Rectangle 26"/>
+          <p:cNvPr id="26" name="Rounded Rectangle 25"/>
           <p:cNvSpPr/>
           <p:nvPr/>
         </p:nvSpPr>
@@ -22364,7 +21968,7 @@
       </p:sp>
       <p:pic>
         <p:nvPicPr>
-          <p:cNvPr id="28" name="Picture 27" descr="brain_e1542a.png"/>
+          <p:cNvPr id="27" name="Picture 26" descr="brain_e1542a.png"/>
           <p:cNvPicPr>
             <a:picLocks noChangeAspect="1"/>
           </p:cNvPicPr>
@@ -22388,7 +21992,7 @@
       </p:pic>
       <p:sp>
         <p:nvSpPr>
-          <p:cNvPr id="29" name="TextBox 28"/>
+          <p:cNvPr id="28" name="TextBox 27"/>
           <p:cNvSpPr txBox="1"/>
           <p:nvPr/>
         </p:nvSpPr>
@@ -22434,7 +22038,7 @@
       </p:sp>
       <p:sp>
         <p:nvSpPr>
-          <p:cNvPr id="30" name="TextBox 29"/>
+          <p:cNvPr id="29" name="TextBox 28"/>
           <p:cNvSpPr txBox="1"/>
           <p:nvPr/>
         </p:nvSpPr>
@@ -22480,7 +22084,7 @@
       </p:sp>
       <p:sp>
         <p:nvSpPr>
-          <p:cNvPr id="31" name="Rounded Rectangle 30"/>
+          <p:cNvPr id="30" name="Rounded Rectangle 29"/>
           <p:cNvSpPr/>
           <p:nvPr/>
         </p:nvSpPr>
@@ -22528,7 +22132,7 @@
       </p:sp>
       <p:sp>
         <p:nvSpPr>
-          <p:cNvPr id="32" name="Rounded Rectangle 31"/>
+          <p:cNvPr id="31" name="Rounded Rectangle 30"/>
           <p:cNvSpPr/>
           <p:nvPr/>
         </p:nvSpPr>
@@ -22574,7 +22178,7 @@
       </p:sp>
       <p:pic>
         <p:nvPicPr>
-          <p:cNvPr id="33" name="Picture 32" descr="unplug_e1542a.png"/>
+          <p:cNvPr id="32" name="Picture 31" descr="unplug_e1542a.png"/>
           <p:cNvPicPr>
             <a:picLocks noChangeAspect="1"/>
           </p:cNvPicPr>
@@ -22598,7 +22202,7 @@
       </p:pic>
       <p:sp>
         <p:nvSpPr>
-          <p:cNvPr id="34" name="TextBox 33"/>
+          <p:cNvPr id="33" name="TextBox 32"/>
           <p:cNvSpPr txBox="1"/>
           <p:nvPr/>
         </p:nvSpPr>
@@ -22644,7 +22248,7 @@
       </p:sp>
       <p:sp>
         <p:nvSpPr>
-          <p:cNvPr id="35" name="TextBox 34"/>
+          <p:cNvPr id="34" name="TextBox 33"/>
           <p:cNvSpPr txBox="1"/>
           <p:nvPr/>
         </p:nvSpPr>
@@ -22690,7 +22294,7 @@
       </p:sp>
       <p:cxnSp>
         <p:nvCxnSpPr>
-          <p:cNvPr id="36" name="Connector 35"/>
+          <p:cNvPr id="35" name="Connector 34"/>
           <p:cNvCxnSpPr/>
           <p:nvPr/>
         </p:nvCxnSpPr>
@@ -22698,6 +22302,42 @@
           <a:xfrm flipV="1">
             <a:off x="8284464" y="4736592"/>
             <a:ext cx="0" cy="137160"/>
+          </a:xfrm>
+          <a:prstGeom prst="line">
+            <a:avLst/>
+          </a:prstGeom>
+          <a:ln w="9525">
+            <a:solidFill>
+              <a:srgbClr val="D9D3C6"/>
+            </a:solidFill>
+          </a:ln>
+          <a:effectLst/>
+        </p:spPr>
+        <p:style>
+          <a:lnRef idx="2">
+            <a:schemeClr val="accent1"/>
+          </a:lnRef>
+          <a:fillRef idx="0">
+            <a:schemeClr val="accent1"/>
+          </a:fillRef>
+          <a:effectRef idx="1">
+            <a:schemeClr val="accent1"/>
+          </a:effectRef>
+          <a:fontRef idx="minor">
+            <a:schemeClr val="tx1"/>
+          </a:fontRef>
+        </p:style>
+      </p:cxnSp>
+      <p:cxnSp>
+        <p:nvCxnSpPr>
+          <p:cNvPr id="36" name="Connector 35"/>
+          <p:cNvCxnSpPr/>
+          <p:nvPr/>
+        </p:nvCxnSpPr>
+        <p:spPr>
+          <a:xfrm flipV="1">
+            <a:off x="8284464" y="4805172"/>
+            <a:ext cx="118784" cy="68580"/>
           </a:xfrm>
           <a:prstGeom prst="line">
             <a:avLst/>
@@ -22731,8 +22371,8 @@
           <p:nvPr/>
         </p:nvCxnSpPr>
         <p:spPr>
-          <a:xfrm flipV="1">
-            <a:off x="8284464" y="4805172"/>
+          <a:xfrm>
+            <a:off x="8284464" y="4873752"/>
             <a:ext cx="118784" cy="68580"/>
           </a:xfrm>
           <a:prstGeom prst="line">
@@ -22769,7 +22409,7 @@
         <p:spPr>
           <a:xfrm>
             <a:off x="8284464" y="4873752"/>
-            <a:ext cx="118784" cy="68580"/>
+            <a:ext cx="0" cy="137160"/>
           </a:xfrm>
           <a:prstGeom prst="line">
             <a:avLst/>
@@ -22803,9 +22443,9 @@
           <p:nvPr/>
         </p:nvCxnSpPr>
         <p:spPr>
-          <a:xfrm>
-            <a:off x="8284464" y="4873752"/>
-            <a:ext cx="0" cy="137160"/>
+          <a:xfrm flipH="1">
+            <a:off x="8165679" y="4873752"/>
+            <a:ext cx="118785" cy="68580"/>
           </a:xfrm>
           <a:prstGeom prst="line">
             <a:avLst/>
@@ -22839,8 +22479,8 @@
           <p:nvPr/>
         </p:nvCxnSpPr>
         <p:spPr>
-          <a:xfrm flipH="1">
-            <a:off x="8165679" y="4873752"/>
+          <a:xfrm flipH="1" flipV="1">
+            <a:off x="8165679" y="4805172"/>
             <a:ext cx="118785" cy="68580"/>
           </a:xfrm>
           <a:prstGeom prst="line">
@@ -22868,45 +22508,9 @@
           </a:fontRef>
         </p:style>
       </p:cxnSp>
-      <p:cxnSp>
-        <p:nvCxnSpPr>
-          <p:cNvPr id="41" name="Connector 40"/>
-          <p:cNvCxnSpPr/>
-          <p:nvPr/>
-        </p:nvCxnSpPr>
-        <p:spPr>
-          <a:xfrm flipH="1" flipV="1">
-            <a:off x="8165679" y="4805172"/>
-            <a:ext cx="118785" cy="68580"/>
-          </a:xfrm>
-          <a:prstGeom prst="line">
-            <a:avLst/>
-          </a:prstGeom>
-          <a:ln w="9525">
-            <a:solidFill>
-              <a:srgbClr val="D9D3C6"/>
-            </a:solidFill>
-          </a:ln>
-          <a:effectLst/>
-        </p:spPr>
-        <p:style>
-          <a:lnRef idx="2">
-            <a:schemeClr val="accent1"/>
-          </a:lnRef>
-          <a:fillRef idx="0">
-            <a:schemeClr val="accent1"/>
-          </a:fillRef>
-          <a:effectRef idx="1">
-            <a:schemeClr val="accent1"/>
-          </a:effectRef>
-          <a:fontRef idx="minor">
-            <a:schemeClr val="tx1"/>
-          </a:fontRef>
-        </p:style>
-      </p:cxnSp>
-      <p:sp>
-        <p:nvSpPr>
-          <p:cNvPr id="42" name="Rounded Rectangle 41"/>
+      <p:sp>
+        <p:nvSpPr>
+          <p:cNvPr id="41" name="Rounded Rectangle 40"/>
           <p:cNvSpPr/>
           <p:nvPr/>
         </p:nvSpPr>
@@ -22952,7 +22556,7 @@
       </p:sp>
       <p:sp>
         <p:nvSpPr>
-          <p:cNvPr id="43" name="Rounded Rectangle 42"/>
+          <p:cNvPr id="42" name="Rounded Rectangle 41"/>
           <p:cNvSpPr/>
           <p:nvPr/>
         </p:nvSpPr>
@@ -22998,7 +22602,7 @@
       </p:sp>
       <p:sp>
         <p:nvSpPr>
-          <p:cNvPr id="44" name="Rounded Rectangle 43"/>
+          <p:cNvPr id="43" name="Rounded Rectangle 42"/>
           <p:cNvSpPr/>
           <p:nvPr/>
         </p:nvSpPr>
@@ -23044,7 +22648,7 @@
       </p:sp>
       <p:sp>
         <p:nvSpPr>
-          <p:cNvPr id="45" name="Rounded Rectangle 44"/>
+          <p:cNvPr id="44" name="Rounded Rectangle 43"/>
           <p:cNvSpPr/>
           <p:nvPr/>
         </p:nvSpPr>
@@ -23090,7 +22694,7 @@
       </p:sp>
       <p:sp>
         <p:nvSpPr>
-          <p:cNvPr id="46" name="Rounded Rectangle 45"/>
+          <p:cNvPr id="45" name="Rounded Rectangle 44"/>
           <p:cNvSpPr/>
           <p:nvPr/>
         </p:nvSpPr>
@@ -23136,7 +22740,7 @@
       </p:sp>
       <p:sp>
         <p:nvSpPr>
-          <p:cNvPr id="47" name="Rounded Rectangle 46"/>
+          <p:cNvPr id="46" name="Rounded Rectangle 45"/>
           <p:cNvSpPr/>
           <p:nvPr/>
         </p:nvSpPr>
@@ -23182,7 +22786,7 @@
       </p:sp>
       <p:sp>
         <p:nvSpPr>
-          <p:cNvPr id="48" name="Rounded Rectangle 47"/>
+          <p:cNvPr id="47" name="Rounded Rectangle 46"/>
           <p:cNvSpPr/>
           <p:nvPr/>
         </p:nvSpPr>
@@ -23228,7 +22832,7 @@
       </p:sp>
       <p:sp>
         <p:nvSpPr>
-          <p:cNvPr id="49" name="TextBox 48"/>
+          <p:cNvPr id="48" name="TextBox 47"/>
           <p:cNvSpPr txBox="1"/>
           <p:nvPr/>
         </p:nvSpPr>
@@ -23274,7 +22878,7 @@
       </p:sp>
       <p:sp>
         <p:nvSpPr>
-          <p:cNvPr id="50" name="TextBox 49"/>
+          <p:cNvPr id="49" name="TextBox 48"/>
           <p:cNvSpPr txBox="1"/>
           <p:nvPr/>
         </p:nvSpPr>

</xml_diff>